<commit_message>
Update PowerPoint for song #4 in FUBC - English
</commit_message>
<xml_diff>
--- a/fubc-en/4-God Is Good All the Time.pptx
+++ b/fubc-en/4-God Is Good All the Time.pptx
@@ -11,9 +11,15 @@
     <p:sldId id="259" r:id="rId5"/>
     <p:sldId id="260" r:id="rId6"/>
     <p:sldId id="261" r:id="rId7"/>
+    <p:sldId id="262" r:id="rId8"/>
+    <p:sldId id="263" r:id="rId9"/>
+    <p:sldId id="264" r:id="rId10"/>
+    <p:sldId id="265" r:id="rId11"/>
+    <p:sldId id="266" r:id="rId12"/>
+    <p:sldId id="267" r:id="rId13"/>
   </p:sldIdLst>
   <p:notesMasterIdLst>
-    <p:notesMasterId r:id="rId8"/>
+    <p:notesMasterId r:id="rId14"/>
   </p:notesMasterIdLst>
   <p:sldSz cx="12192000" cy="6858000"/>
   <p:notesSz cx="6858000" cy="12192000"/>
@@ -549,6 +555,270 @@
 </p:notes>
 </file>
 
+<file path=ppt/notesSlides/notesSlide10.xml><?xml version="1.0" encoding="utf-8"?>
+<p:notes xmlns:a="http://schemas.openxmlformats.org/drawingml/2006/main" xmlns:r="http://schemas.openxmlformats.org/officeDocument/2006/relationships" xmlns:p="http://schemas.openxmlformats.org/presentationml/2006/main">
+  <p:cSld>
+    <p:spTree>
+      <p:nvGrpSpPr>
+        <p:cNvPr id="1" name=""/>
+        <p:cNvGrpSpPr/>
+        <p:nvPr/>
+      </p:nvGrpSpPr>
+      <p:grpSpPr>
+        <a:xfrm>
+          <a:off x="0" y="0"/>
+          <a:ext cx="0" cy="0"/>
+          <a:chOff x="0" y="0"/>
+          <a:chExt cx="0" cy="0"/>
+        </a:xfrm>
+      </p:grpSpPr>
+      <p:sp>
+        <p:nvSpPr>
+          <p:cNvPr id="2" name="Slide Image Placeholder 1"/>
+          <p:cNvSpPr>
+            <a:spLocks noGrp="1" noRot="1" noChangeAspect="1"/>
+          </p:cNvSpPr>
+          <p:nvPr>
+            <p:ph type="sldImg"/>
+          </p:nvPr>
+        </p:nvSpPr>
+        <p:spPr/>
+      </p:sp>
+      <p:sp>
+        <p:nvSpPr>
+          <p:cNvPr id="3" name="Notes Placeholder 2"/>
+          <p:cNvSpPr>
+            <a:spLocks noGrp="1"/>
+          </p:cNvSpPr>
+          <p:nvPr>
+            <p:ph type="body" idx="1"/>
+          </p:nvPr>
+        </p:nvSpPr>
+        <p:spPr/>
+        <p:txBody>
+          <a:bodyPr/>
+          <a:lstStyle/>
+          <a:p>
+            <a:r>
+              <a:rPr lang="en-US" dirty="0"/>
+              <a:t/>
+            </a:r>
+            <a:endParaRPr lang="en-US" dirty="0"/>
+          </a:p>
+        </p:txBody>
+      </p:sp>
+      <p:sp>
+        <p:nvSpPr>
+          <p:cNvPr id="4" name="Slide Number Placeholder 3"/>
+          <p:cNvSpPr>
+            <a:spLocks noGrp="1"/>
+          </p:cNvSpPr>
+          <p:nvPr>
+            <p:ph type="sldNum" sz="quarter" idx="10"/>
+          </p:nvPr>
+        </p:nvSpPr>
+        <p:spPr/>
+        <p:txBody>
+          <a:bodyPr/>
+          <a:lstStyle/>
+          <a:p>
+            <a:fld id="{F7021451-1387-4CA6-816F-3879F97B5CBC}" type="slidenum">
+              <a:rPr lang="en-US"/>
+              <a:t>10</a:t>
+            </a:fld>
+            <a:endParaRPr lang="en-US"/>
+          </a:p>
+        </p:txBody>
+      </p:sp>
+    </p:spTree>
+    <p:extLst>
+      <p:ext uri="{BB962C8B-B14F-4D97-AF65-F5344CB8AC3E}">
+        <p14:creationId xmlns:p14="http://schemas.microsoft.com/office/powerpoint/2010/main" val="1024086991"/>
+      </p:ext>
+    </p:extLst>
+  </p:cSld>
+  <p:clrMapOvr>
+    <a:masterClrMapping/>
+  </p:clrMapOvr>
+</p:notes>
+</file>
+
+<file path=ppt/notesSlides/notesSlide11.xml><?xml version="1.0" encoding="utf-8"?>
+<p:notes xmlns:a="http://schemas.openxmlformats.org/drawingml/2006/main" xmlns:r="http://schemas.openxmlformats.org/officeDocument/2006/relationships" xmlns:p="http://schemas.openxmlformats.org/presentationml/2006/main">
+  <p:cSld>
+    <p:spTree>
+      <p:nvGrpSpPr>
+        <p:cNvPr id="1" name=""/>
+        <p:cNvGrpSpPr/>
+        <p:nvPr/>
+      </p:nvGrpSpPr>
+      <p:grpSpPr>
+        <a:xfrm>
+          <a:off x="0" y="0"/>
+          <a:ext cx="0" cy="0"/>
+          <a:chOff x="0" y="0"/>
+          <a:chExt cx="0" cy="0"/>
+        </a:xfrm>
+      </p:grpSpPr>
+      <p:sp>
+        <p:nvSpPr>
+          <p:cNvPr id="2" name="Slide Image Placeholder 1"/>
+          <p:cNvSpPr>
+            <a:spLocks noGrp="1" noRot="1" noChangeAspect="1"/>
+          </p:cNvSpPr>
+          <p:nvPr>
+            <p:ph type="sldImg"/>
+          </p:nvPr>
+        </p:nvSpPr>
+        <p:spPr/>
+      </p:sp>
+      <p:sp>
+        <p:nvSpPr>
+          <p:cNvPr id="3" name="Notes Placeholder 2"/>
+          <p:cNvSpPr>
+            <a:spLocks noGrp="1"/>
+          </p:cNvSpPr>
+          <p:nvPr>
+            <p:ph type="body" idx="1"/>
+          </p:nvPr>
+        </p:nvSpPr>
+        <p:spPr/>
+        <p:txBody>
+          <a:bodyPr/>
+          <a:lstStyle/>
+          <a:p>
+            <a:r>
+              <a:rPr lang="en-US" dirty="0"/>
+              <a:t/>
+            </a:r>
+            <a:endParaRPr lang="en-US" dirty="0"/>
+          </a:p>
+        </p:txBody>
+      </p:sp>
+      <p:sp>
+        <p:nvSpPr>
+          <p:cNvPr id="4" name="Slide Number Placeholder 3"/>
+          <p:cNvSpPr>
+            <a:spLocks noGrp="1"/>
+          </p:cNvSpPr>
+          <p:nvPr>
+            <p:ph type="sldNum" sz="quarter" idx="10"/>
+          </p:nvPr>
+        </p:nvSpPr>
+        <p:spPr/>
+        <p:txBody>
+          <a:bodyPr/>
+          <a:lstStyle/>
+          <a:p>
+            <a:fld id="{F7021451-1387-4CA6-816F-3879F97B5CBC}" type="slidenum">
+              <a:rPr lang="en-US"/>
+              <a:t>11</a:t>
+            </a:fld>
+            <a:endParaRPr lang="en-US"/>
+          </a:p>
+        </p:txBody>
+      </p:sp>
+    </p:spTree>
+    <p:extLst>
+      <p:ext uri="{BB962C8B-B14F-4D97-AF65-F5344CB8AC3E}">
+        <p14:creationId xmlns:p14="http://schemas.microsoft.com/office/powerpoint/2010/main" val="1024086991"/>
+      </p:ext>
+    </p:extLst>
+  </p:cSld>
+  <p:clrMapOvr>
+    <a:masterClrMapping/>
+  </p:clrMapOvr>
+</p:notes>
+</file>
+
+<file path=ppt/notesSlides/notesSlide12.xml><?xml version="1.0" encoding="utf-8"?>
+<p:notes xmlns:a="http://schemas.openxmlformats.org/drawingml/2006/main" xmlns:r="http://schemas.openxmlformats.org/officeDocument/2006/relationships" xmlns:p="http://schemas.openxmlformats.org/presentationml/2006/main">
+  <p:cSld>
+    <p:spTree>
+      <p:nvGrpSpPr>
+        <p:cNvPr id="1" name=""/>
+        <p:cNvGrpSpPr/>
+        <p:nvPr/>
+      </p:nvGrpSpPr>
+      <p:grpSpPr>
+        <a:xfrm>
+          <a:off x="0" y="0"/>
+          <a:ext cx="0" cy="0"/>
+          <a:chOff x="0" y="0"/>
+          <a:chExt cx="0" cy="0"/>
+        </a:xfrm>
+      </p:grpSpPr>
+      <p:sp>
+        <p:nvSpPr>
+          <p:cNvPr id="2" name="Slide Image Placeholder 1"/>
+          <p:cNvSpPr>
+            <a:spLocks noGrp="1" noRot="1" noChangeAspect="1"/>
+          </p:cNvSpPr>
+          <p:nvPr>
+            <p:ph type="sldImg"/>
+          </p:nvPr>
+        </p:nvSpPr>
+        <p:spPr/>
+      </p:sp>
+      <p:sp>
+        <p:nvSpPr>
+          <p:cNvPr id="3" name="Notes Placeholder 2"/>
+          <p:cNvSpPr>
+            <a:spLocks noGrp="1"/>
+          </p:cNvSpPr>
+          <p:nvPr>
+            <p:ph type="body" idx="1"/>
+          </p:nvPr>
+        </p:nvSpPr>
+        <p:spPr/>
+        <p:txBody>
+          <a:bodyPr/>
+          <a:lstStyle/>
+          <a:p>
+            <a:r>
+              <a:rPr lang="en-US" dirty="0"/>
+              <a:t/>
+            </a:r>
+            <a:endParaRPr lang="en-US" dirty="0"/>
+          </a:p>
+        </p:txBody>
+      </p:sp>
+      <p:sp>
+        <p:nvSpPr>
+          <p:cNvPr id="4" name="Slide Number Placeholder 3"/>
+          <p:cNvSpPr>
+            <a:spLocks noGrp="1"/>
+          </p:cNvSpPr>
+          <p:nvPr>
+            <p:ph type="sldNum" sz="quarter" idx="10"/>
+          </p:nvPr>
+        </p:nvSpPr>
+        <p:spPr/>
+        <p:txBody>
+          <a:bodyPr/>
+          <a:lstStyle/>
+          <a:p>
+            <a:fld id="{F7021451-1387-4CA6-816F-3879F97B5CBC}" type="slidenum">
+              <a:rPr lang="en-US"/>
+              <a:t>12</a:t>
+            </a:fld>
+            <a:endParaRPr lang="en-US"/>
+          </a:p>
+        </p:txBody>
+      </p:sp>
+    </p:spTree>
+    <p:extLst>
+      <p:ext uri="{BB962C8B-B14F-4D97-AF65-F5344CB8AC3E}">
+        <p14:creationId xmlns:p14="http://schemas.microsoft.com/office/powerpoint/2010/main" val="1024086991"/>
+      </p:ext>
+    </p:extLst>
+  </p:cSld>
+  <p:clrMapOvr>
+    <a:masterClrMapping/>
+  </p:clrMapOvr>
+</p:notes>
+</file>
+
 <file path=ppt/notesSlides/notesSlide2.xml><?xml version="1.0" encoding="utf-8"?>
 <p:notes xmlns:a="http://schemas.openxmlformats.org/drawingml/2006/main" xmlns:r="http://schemas.openxmlformats.org/officeDocument/2006/relationships" xmlns:p="http://schemas.openxmlformats.org/presentationml/2006/main">
   <p:cSld>
@@ -971,6 +1241,270 @@
             <a:fld id="{F7021451-1387-4CA6-816F-3879F97B5CBC}" type="slidenum">
               <a:rPr lang="en-US"/>
               <a:t>6</a:t>
+            </a:fld>
+            <a:endParaRPr lang="en-US"/>
+          </a:p>
+        </p:txBody>
+      </p:sp>
+    </p:spTree>
+    <p:extLst>
+      <p:ext uri="{BB962C8B-B14F-4D97-AF65-F5344CB8AC3E}">
+        <p14:creationId xmlns:p14="http://schemas.microsoft.com/office/powerpoint/2010/main" val="1024086991"/>
+      </p:ext>
+    </p:extLst>
+  </p:cSld>
+  <p:clrMapOvr>
+    <a:masterClrMapping/>
+  </p:clrMapOvr>
+</p:notes>
+</file>
+
+<file path=ppt/notesSlides/notesSlide7.xml><?xml version="1.0" encoding="utf-8"?>
+<p:notes xmlns:a="http://schemas.openxmlformats.org/drawingml/2006/main" xmlns:r="http://schemas.openxmlformats.org/officeDocument/2006/relationships" xmlns:p="http://schemas.openxmlformats.org/presentationml/2006/main">
+  <p:cSld>
+    <p:spTree>
+      <p:nvGrpSpPr>
+        <p:cNvPr id="1" name=""/>
+        <p:cNvGrpSpPr/>
+        <p:nvPr/>
+      </p:nvGrpSpPr>
+      <p:grpSpPr>
+        <a:xfrm>
+          <a:off x="0" y="0"/>
+          <a:ext cx="0" cy="0"/>
+          <a:chOff x="0" y="0"/>
+          <a:chExt cx="0" cy="0"/>
+        </a:xfrm>
+      </p:grpSpPr>
+      <p:sp>
+        <p:nvSpPr>
+          <p:cNvPr id="2" name="Slide Image Placeholder 1"/>
+          <p:cNvSpPr>
+            <a:spLocks noGrp="1" noRot="1" noChangeAspect="1"/>
+          </p:cNvSpPr>
+          <p:nvPr>
+            <p:ph type="sldImg"/>
+          </p:nvPr>
+        </p:nvSpPr>
+        <p:spPr/>
+      </p:sp>
+      <p:sp>
+        <p:nvSpPr>
+          <p:cNvPr id="3" name="Notes Placeholder 2"/>
+          <p:cNvSpPr>
+            <a:spLocks noGrp="1"/>
+          </p:cNvSpPr>
+          <p:nvPr>
+            <p:ph type="body" idx="1"/>
+          </p:nvPr>
+        </p:nvSpPr>
+        <p:spPr/>
+        <p:txBody>
+          <a:bodyPr/>
+          <a:lstStyle/>
+          <a:p>
+            <a:r>
+              <a:rPr lang="en-US" dirty="0"/>
+              <a:t/>
+            </a:r>
+            <a:endParaRPr lang="en-US" dirty="0"/>
+          </a:p>
+        </p:txBody>
+      </p:sp>
+      <p:sp>
+        <p:nvSpPr>
+          <p:cNvPr id="4" name="Slide Number Placeholder 3"/>
+          <p:cNvSpPr>
+            <a:spLocks noGrp="1"/>
+          </p:cNvSpPr>
+          <p:nvPr>
+            <p:ph type="sldNum" sz="quarter" idx="10"/>
+          </p:nvPr>
+        </p:nvSpPr>
+        <p:spPr/>
+        <p:txBody>
+          <a:bodyPr/>
+          <a:lstStyle/>
+          <a:p>
+            <a:fld id="{F7021451-1387-4CA6-816F-3879F97B5CBC}" type="slidenum">
+              <a:rPr lang="en-US"/>
+              <a:t>7</a:t>
+            </a:fld>
+            <a:endParaRPr lang="en-US"/>
+          </a:p>
+        </p:txBody>
+      </p:sp>
+    </p:spTree>
+    <p:extLst>
+      <p:ext uri="{BB962C8B-B14F-4D97-AF65-F5344CB8AC3E}">
+        <p14:creationId xmlns:p14="http://schemas.microsoft.com/office/powerpoint/2010/main" val="1024086991"/>
+      </p:ext>
+    </p:extLst>
+  </p:cSld>
+  <p:clrMapOvr>
+    <a:masterClrMapping/>
+  </p:clrMapOvr>
+</p:notes>
+</file>
+
+<file path=ppt/notesSlides/notesSlide8.xml><?xml version="1.0" encoding="utf-8"?>
+<p:notes xmlns:a="http://schemas.openxmlformats.org/drawingml/2006/main" xmlns:r="http://schemas.openxmlformats.org/officeDocument/2006/relationships" xmlns:p="http://schemas.openxmlformats.org/presentationml/2006/main">
+  <p:cSld>
+    <p:spTree>
+      <p:nvGrpSpPr>
+        <p:cNvPr id="1" name=""/>
+        <p:cNvGrpSpPr/>
+        <p:nvPr/>
+      </p:nvGrpSpPr>
+      <p:grpSpPr>
+        <a:xfrm>
+          <a:off x="0" y="0"/>
+          <a:ext cx="0" cy="0"/>
+          <a:chOff x="0" y="0"/>
+          <a:chExt cx="0" cy="0"/>
+        </a:xfrm>
+      </p:grpSpPr>
+      <p:sp>
+        <p:nvSpPr>
+          <p:cNvPr id="2" name="Slide Image Placeholder 1"/>
+          <p:cNvSpPr>
+            <a:spLocks noGrp="1" noRot="1" noChangeAspect="1"/>
+          </p:cNvSpPr>
+          <p:nvPr>
+            <p:ph type="sldImg"/>
+          </p:nvPr>
+        </p:nvSpPr>
+        <p:spPr/>
+      </p:sp>
+      <p:sp>
+        <p:nvSpPr>
+          <p:cNvPr id="3" name="Notes Placeholder 2"/>
+          <p:cNvSpPr>
+            <a:spLocks noGrp="1"/>
+          </p:cNvSpPr>
+          <p:nvPr>
+            <p:ph type="body" idx="1"/>
+          </p:nvPr>
+        </p:nvSpPr>
+        <p:spPr/>
+        <p:txBody>
+          <a:bodyPr/>
+          <a:lstStyle/>
+          <a:p>
+            <a:r>
+              <a:rPr lang="en-US" dirty="0"/>
+              <a:t/>
+            </a:r>
+            <a:endParaRPr lang="en-US" dirty="0"/>
+          </a:p>
+        </p:txBody>
+      </p:sp>
+      <p:sp>
+        <p:nvSpPr>
+          <p:cNvPr id="4" name="Slide Number Placeholder 3"/>
+          <p:cNvSpPr>
+            <a:spLocks noGrp="1"/>
+          </p:cNvSpPr>
+          <p:nvPr>
+            <p:ph type="sldNum" sz="quarter" idx="10"/>
+          </p:nvPr>
+        </p:nvSpPr>
+        <p:spPr/>
+        <p:txBody>
+          <a:bodyPr/>
+          <a:lstStyle/>
+          <a:p>
+            <a:fld id="{F7021451-1387-4CA6-816F-3879F97B5CBC}" type="slidenum">
+              <a:rPr lang="en-US"/>
+              <a:t>8</a:t>
+            </a:fld>
+            <a:endParaRPr lang="en-US"/>
+          </a:p>
+        </p:txBody>
+      </p:sp>
+    </p:spTree>
+    <p:extLst>
+      <p:ext uri="{BB962C8B-B14F-4D97-AF65-F5344CB8AC3E}">
+        <p14:creationId xmlns:p14="http://schemas.microsoft.com/office/powerpoint/2010/main" val="1024086991"/>
+      </p:ext>
+    </p:extLst>
+  </p:cSld>
+  <p:clrMapOvr>
+    <a:masterClrMapping/>
+  </p:clrMapOvr>
+</p:notes>
+</file>
+
+<file path=ppt/notesSlides/notesSlide9.xml><?xml version="1.0" encoding="utf-8"?>
+<p:notes xmlns:a="http://schemas.openxmlformats.org/drawingml/2006/main" xmlns:r="http://schemas.openxmlformats.org/officeDocument/2006/relationships" xmlns:p="http://schemas.openxmlformats.org/presentationml/2006/main">
+  <p:cSld>
+    <p:spTree>
+      <p:nvGrpSpPr>
+        <p:cNvPr id="1" name=""/>
+        <p:cNvGrpSpPr/>
+        <p:nvPr/>
+      </p:nvGrpSpPr>
+      <p:grpSpPr>
+        <a:xfrm>
+          <a:off x="0" y="0"/>
+          <a:ext cx="0" cy="0"/>
+          <a:chOff x="0" y="0"/>
+          <a:chExt cx="0" cy="0"/>
+        </a:xfrm>
+      </p:grpSpPr>
+      <p:sp>
+        <p:nvSpPr>
+          <p:cNvPr id="2" name="Slide Image Placeholder 1"/>
+          <p:cNvSpPr>
+            <a:spLocks noGrp="1" noRot="1" noChangeAspect="1"/>
+          </p:cNvSpPr>
+          <p:nvPr>
+            <p:ph type="sldImg"/>
+          </p:nvPr>
+        </p:nvSpPr>
+        <p:spPr/>
+      </p:sp>
+      <p:sp>
+        <p:nvSpPr>
+          <p:cNvPr id="3" name="Notes Placeholder 2"/>
+          <p:cNvSpPr>
+            <a:spLocks noGrp="1"/>
+          </p:cNvSpPr>
+          <p:nvPr>
+            <p:ph type="body" idx="1"/>
+          </p:nvPr>
+        </p:nvSpPr>
+        <p:spPr/>
+        <p:txBody>
+          <a:bodyPr/>
+          <a:lstStyle/>
+          <a:p>
+            <a:r>
+              <a:rPr lang="en-US" dirty="0"/>
+              <a:t/>
+            </a:r>
+            <a:endParaRPr lang="en-US" dirty="0"/>
+          </a:p>
+        </p:txBody>
+      </p:sp>
+      <p:sp>
+        <p:nvSpPr>
+          <p:cNvPr id="4" name="Slide Number Placeholder 3"/>
+          <p:cNvSpPr>
+            <a:spLocks noGrp="1"/>
+          </p:cNvSpPr>
+          <p:nvPr>
+            <p:ph type="sldNum" sz="quarter" idx="10"/>
+          </p:nvPr>
+        </p:nvSpPr>
+        <p:spPr/>
+        <p:txBody>
+          <a:bodyPr/>
+          <a:lstStyle/>
+          <a:p>
+            <a:fld id="{F7021451-1387-4CA6-816F-3879F97B5CBC}" type="slidenum">
+              <a:rPr lang="en-US"/>
+              <a:t>9</a:t>
             </a:fld>
             <a:endParaRPr lang="en-US"/>
           </a:p>
@@ -1353,7 +1887,7 @@
                 <a:ea typeface="Arial" pitchFamily="34" charset="-122"/>
                 <a:cs typeface="Arial" pitchFamily="34" charset="-120"/>
               </a:rPr>
-              <a:t>If you're walkin, through the valley, and there are shadows all around,</a:t>
+              <a:t>If you're walkin, through the valley,</a:t>
             </a:r>
             <a:endParaRPr lang="en-US" sz="4000" dirty="0"/>
           </a:p>
@@ -1370,7 +1904,7 @@
                 <a:ea typeface="Arial" pitchFamily="34" charset="-122"/>
                 <a:cs typeface="Arial" pitchFamily="34" charset="-120"/>
               </a:rPr>
-              <a:t>Do not fear, He will guide you. He will keep you safe and sound</a:t>
+              <a:t>and there are shadows all around,</a:t>
             </a:r>
             <a:endParaRPr lang="en-US" sz="4000" dirty="0"/>
           </a:p>
@@ -1387,7 +1921,7 @@
                 <a:ea typeface="Arial" pitchFamily="34" charset="-122"/>
                 <a:cs typeface="Arial" pitchFamily="34" charset="-120"/>
               </a:rPr>
-              <a:t>'Cause He has promised to never leave you nor forsake you</a:t>
+              <a:t>Do not fear, He will guide you.</a:t>
             </a:r>
             <a:endParaRPr lang="en-US" sz="4000" dirty="0"/>
           </a:p>
@@ -1404,7 +1938,407 @@
                 <a:ea typeface="Arial" pitchFamily="34" charset="-122"/>
                 <a:cs typeface="Arial" pitchFamily="34" charset="-120"/>
               </a:rPr>
+              <a:t>He will keep you safe and sound</a:t>
+            </a:r>
+            <a:endParaRPr lang="en-US" sz="4000" dirty="0"/>
+          </a:p>
+        </p:txBody>
+      </p:sp>
+    </p:spTree>
+  </p:cSld>
+  <p:clrMapOvr>
+    <a:masterClrMapping/>
+  </p:clrMapOvr>
+</p:sld>
+</file>
+
+<file path=ppt/slides/slide10.xml><?xml version="1.0" encoding="utf-8"?>
+<p:sld xmlns:a="http://schemas.openxmlformats.org/drawingml/2006/main" xmlns:r="http://schemas.openxmlformats.org/officeDocument/2006/relationships" xmlns:p="http://schemas.openxmlformats.org/presentationml/2006/main">
+  <p:cSld name="Slide 10">
+    <p:bg>
+      <p:bgPr>
+        <a:solidFill>
+          <a:srgbClr val="000000"/>
+        </a:solidFill>
+      </p:bgPr>
+    </p:bg>
+    <p:spTree>
+      <p:nvGrpSpPr>
+        <p:cNvPr id="1" name=""/>
+        <p:cNvGrpSpPr/>
+        <p:nvPr/>
+      </p:nvGrpSpPr>
+      <p:grpSpPr>
+        <a:xfrm>
+          <a:off x="0" y="0"/>
+          <a:ext cx="0" cy="0"/>
+          <a:chOff x="0" y="0"/>
+          <a:chExt cx="0" cy="0"/>
+        </a:xfrm>
+      </p:grpSpPr>
+      <p:sp>
+        <p:nvSpPr>
+          <p:cNvPr id="2" name="Text 0"/>
+          <p:cNvSpPr txBox="1"/>
+          <p:nvPr/>
+        </p:nvSpPr>
+        <p:spPr>
+          <a:xfrm>
+            <a:off x="548640" y="457200"/>
+            <a:ext cx="11064240" cy="5943600"/>
+          </a:xfrm>
+          <a:prstGeom prst="rect">
+            <a:avLst/>
+          </a:prstGeom>
+          <a:noFill/>
+          <a:ln/>
+        </p:spPr>
+        <p:txBody>
+          <a:bodyPr wrap="square" lIns="0" tIns="0" rIns="0" bIns="0" rtlCol="0" anchor="ctr"/>
+          <a:lstStyle/>
+          <a:p>
+            <a:pPr algn="ctr" indent="0" marL="0">
+              <a:buNone/>
+            </a:pPr>
+            <a:r>
+              <a:rPr lang="en-US" sz="4000" b="1" dirty="0">
+                <a:solidFill>
+                  <a:srgbClr val="FFFFFF"/>
+                </a:solidFill>
+                <a:latin typeface="Arial" pitchFamily="34" charset="0"/>
+                <a:ea typeface="Arial" pitchFamily="34" charset="-122"/>
+                <a:cs typeface="Arial" pitchFamily="34" charset="-120"/>
+              </a:rPr>
+              <a:t>'Cause He has promised</a:t>
+            </a:r>
+            <a:endParaRPr lang="en-US" sz="4000" dirty="0"/>
+          </a:p>
+          <a:p>
+            <a:pPr algn="ctr" indent="0" marL="0">
+              <a:buNone/>
+            </a:pPr>
+            <a:r>
+              <a:rPr lang="en-US" sz="4000" b="1" dirty="0">
+                <a:solidFill>
+                  <a:srgbClr val="FFFFFF"/>
+                </a:solidFill>
+                <a:latin typeface="Arial" pitchFamily="34" charset="0"/>
+                <a:ea typeface="Arial" pitchFamily="34" charset="-122"/>
+                <a:cs typeface="Arial" pitchFamily="34" charset="-120"/>
+              </a:rPr>
+              <a:t>to never leave you nor forsake you</a:t>
+            </a:r>
+            <a:endParaRPr lang="en-US" sz="4000" dirty="0"/>
+          </a:p>
+          <a:p>
+            <a:pPr algn="ctr" indent="0" marL="0">
+              <a:buNone/>
+            </a:pPr>
+            <a:r>
+              <a:rPr lang="en-US" sz="4000" b="1" dirty="0">
+                <a:solidFill>
+                  <a:srgbClr val="FFFFFF"/>
+                </a:solidFill>
+                <a:latin typeface="Arial" pitchFamily="34" charset="0"/>
+                <a:ea typeface="Arial" pitchFamily="34" charset="-122"/>
+                <a:cs typeface="Arial" pitchFamily="34" charset="-120"/>
+              </a:rPr>
               <a:t>And His Word is true.</a:t>
+            </a:r>
+            <a:endParaRPr lang="en-US" sz="4000" dirty="0"/>
+          </a:p>
+        </p:txBody>
+      </p:sp>
+    </p:spTree>
+  </p:cSld>
+  <p:clrMapOvr>
+    <a:masterClrMapping/>
+  </p:clrMapOvr>
+</p:sld>
+</file>
+
+<file path=ppt/slides/slide11.xml><?xml version="1.0" encoding="utf-8"?>
+<p:sld xmlns:a="http://schemas.openxmlformats.org/drawingml/2006/main" xmlns:r="http://schemas.openxmlformats.org/officeDocument/2006/relationships" xmlns:p="http://schemas.openxmlformats.org/presentationml/2006/main">
+  <p:cSld name="Slide 11">
+    <p:bg>
+      <p:bgPr>
+        <a:solidFill>
+          <a:srgbClr val="000000"/>
+        </a:solidFill>
+      </p:bgPr>
+    </p:bg>
+    <p:spTree>
+      <p:nvGrpSpPr>
+        <p:cNvPr id="1" name=""/>
+        <p:cNvGrpSpPr/>
+        <p:nvPr/>
+      </p:nvGrpSpPr>
+      <p:grpSpPr>
+        <a:xfrm>
+          <a:off x="0" y="0"/>
+          <a:ext cx="0" cy="0"/>
+          <a:chOff x="0" y="0"/>
+          <a:chExt cx="0" cy="0"/>
+        </a:xfrm>
+      </p:grpSpPr>
+      <p:sp>
+        <p:nvSpPr>
+          <p:cNvPr id="2" name="Text 0"/>
+          <p:cNvSpPr txBox="1"/>
+          <p:nvPr/>
+        </p:nvSpPr>
+        <p:spPr>
+          <a:xfrm>
+            <a:off x="548640" y="457200"/>
+            <a:ext cx="11064240" cy="5943600"/>
+          </a:xfrm>
+          <a:prstGeom prst="rect">
+            <a:avLst/>
+          </a:prstGeom>
+          <a:noFill/>
+          <a:ln/>
+        </p:spPr>
+        <p:txBody>
+          <a:bodyPr wrap="square" lIns="0" tIns="0" rIns="0" bIns="0" rtlCol="0" anchor="ctr"/>
+          <a:lstStyle/>
+          <a:p>
+            <a:pPr algn="ctr" indent="0" marL="0">
+              <a:buNone/>
+            </a:pPr>
+            <a:r>
+              <a:rPr lang="en-US" sz="4000" b="1" i="1" dirty="0">
+                <a:solidFill>
+                  <a:srgbClr val="FFFFFF"/>
+                </a:solidFill>
+                <a:latin typeface="Arial" pitchFamily="34" charset="0"/>
+                <a:ea typeface="Arial" pitchFamily="34" charset="-122"/>
+                <a:cs typeface="Arial" pitchFamily="34" charset="-120"/>
+              </a:rPr>
+              <a:t>God is good (God is good)</a:t>
+            </a:r>
+            <a:endParaRPr lang="en-US" sz="4000" dirty="0"/>
+          </a:p>
+          <a:p>
+            <a:pPr algn="ctr" indent="0" marL="0">
+              <a:buNone/>
+            </a:pPr>
+            <a:r>
+              <a:rPr lang="en-US" sz="4000" b="1" i="1" dirty="0">
+                <a:solidFill>
+                  <a:srgbClr val="FFFFFF"/>
+                </a:solidFill>
+                <a:latin typeface="Arial" pitchFamily="34" charset="0"/>
+                <a:ea typeface="Arial" pitchFamily="34" charset="-122"/>
+                <a:cs typeface="Arial" pitchFamily="34" charset="-120"/>
+              </a:rPr>
+              <a:t>all the time (all the time).</a:t>
+            </a:r>
+            <a:endParaRPr lang="en-US" sz="4000" dirty="0"/>
+          </a:p>
+          <a:p>
+            <a:pPr algn="ctr" indent="0" marL="0">
+              <a:buNone/>
+            </a:pPr>
+            <a:r>
+              <a:rPr lang="en-US" sz="4000" b="1" i="1" dirty="0">
+                <a:solidFill>
+                  <a:srgbClr val="FFFFFF"/>
+                </a:solidFill>
+                <a:latin typeface="Arial" pitchFamily="34" charset="0"/>
+                <a:ea typeface="Arial" pitchFamily="34" charset="-122"/>
+                <a:cs typeface="Arial" pitchFamily="34" charset="-120"/>
+              </a:rPr>
+              <a:t>He put a song of praise,</a:t>
+            </a:r>
+            <a:endParaRPr lang="en-US" sz="4000" dirty="0"/>
+          </a:p>
+          <a:p>
+            <a:pPr algn="ctr" indent="0" marL="0">
+              <a:buNone/>
+            </a:pPr>
+            <a:r>
+              <a:rPr lang="en-US" sz="4000" b="1" i="1" dirty="0">
+                <a:solidFill>
+                  <a:srgbClr val="FFFFFF"/>
+                </a:solidFill>
+                <a:latin typeface="Arial" pitchFamily="34" charset="0"/>
+                <a:ea typeface="Arial" pitchFamily="34" charset="-122"/>
+                <a:cs typeface="Arial" pitchFamily="34" charset="-120"/>
+              </a:rPr>
+              <a:t>in this heart of mine.</a:t>
+            </a:r>
+            <a:endParaRPr lang="en-US" sz="4000" dirty="0"/>
+          </a:p>
+          <a:p>
+            <a:pPr algn="ctr" indent="0" marL="0">
+              <a:buNone/>
+            </a:pPr>
+            <a:r>
+              <a:rPr lang="en-US" sz="4000" b="1" i="1" dirty="0">
+                <a:solidFill>
+                  <a:srgbClr val="FFFFFF"/>
+                </a:solidFill>
+                <a:latin typeface="Arial" pitchFamily="34" charset="0"/>
+                <a:ea typeface="Arial" pitchFamily="34" charset="-122"/>
+                <a:cs typeface="Arial" pitchFamily="34" charset="-120"/>
+              </a:rPr>
+              <a:t>God is good (God is good)</a:t>
+            </a:r>
+            <a:endParaRPr lang="en-US" sz="4000" dirty="0"/>
+          </a:p>
+        </p:txBody>
+      </p:sp>
+    </p:spTree>
+  </p:cSld>
+  <p:clrMapOvr>
+    <a:masterClrMapping/>
+  </p:clrMapOvr>
+</p:sld>
+</file>
+
+<file path=ppt/slides/slide12.xml><?xml version="1.0" encoding="utf-8"?>
+<p:sld xmlns:a="http://schemas.openxmlformats.org/drawingml/2006/main" xmlns:r="http://schemas.openxmlformats.org/officeDocument/2006/relationships" xmlns:p="http://schemas.openxmlformats.org/presentationml/2006/main">
+  <p:cSld name="Slide 12">
+    <p:bg>
+      <p:bgPr>
+        <a:solidFill>
+          <a:srgbClr val="000000"/>
+        </a:solidFill>
+      </p:bgPr>
+    </p:bg>
+    <p:spTree>
+      <p:nvGrpSpPr>
+        <p:cNvPr id="1" name=""/>
+        <p:cNvGrpSpPr/>
+        <p:nvPr/>
+      </p:nvGrpSpPr>
+      <p:grpSpPr>
+        <a:xfrm>
+          <a:off x="0" y="0"/>
+          <a:ext cx="0" cy="0"/>
+          <a:chOff x="0" y="0"/>
+          <a:chExt cx="0" cy="0"/>
+        </a:xfrm>
+      </p:grpSpPr>
+      <p:sp>
+        <p:nvSpPr>
+          <p:cNvPr id="2" name="Text 0"/>
+          <p:cNvSpPr txBox="1"/>
+          <p:nvPr/>
+        </p:nvSpPr>
+        <p:spPr>
+          <a:xfrm>
+            <a:off x="548640" y="457200"/>
+            <a:ext cx="11064240" cy="5943600"/>
+          </a:xfrm>
+          <a:prstGeom prst="rect">
+            <a:avLst/>
+          </a:prstGeom>
+          <a:noFill/>
+          <a:ln/>
+        </p:spPr>
+        <p:txBody>
+          <a:bodyPr wrap="square" lIns="0" tIns="0" rIns="0" bIns="0" rtlCol="0" anchor="ctr"/>
+          <a:lstStyle/>
+          <a:p>
+            <a:pPr algn="ctr" indent="0" marL="0">
+              <a:buNone/>
+            </a:pPr>
+            <a:r>
+              <a:rPr lang="en-US" sz="4000" b="1" i="1" dirty="0">
+                <a:solidFill>
+                  <a:srgbClr val="FFFFFF"/>
+                </a:solidFill>
+                <a:latin typeface="Arial" pitchFamily="34" charset="0"/>
+                <a:ea typeface="Arial" pitchFamily="34" charset="-122"/>
+                <a:cs typeface="Arial" pitchFamily="34" charset="-120"/>
+              </a:rPr>
+              <a:t>all the time (all the time).</a:t>
+            </a:r>
+            <a:endParaRPr lang="en-US" sz="4000" dirty="0"/>
+          </a:p>
+          <a:p>
+            <a:pPr algn="ctr" indent="0" marL="0">
+              <a:buNone/>
+            </a:pPr>
+            <a:r>
+              <a:rPr lang="en-US" sz="4000" b="1" i="1" dirty="0">
+                <a:solidFill>
+                  <a:srgbClr val="FFFFFF"/>
+                </a:solidFill>
+                <a:latin typeface="Arial" pitchFamily="34" charset="0"/>
+                <a:ea typeface="Arial" pitchFamily="34" charset="-122"/>
+                <a:cs typeface="Arial" pitchFamily="34" charset="-120"/>
+              </a:rPr>
+              <a:t>Through the darkest night,</a:t>
+            </a:r>
+            <a:endParaRPr lang="en-US" sz="4000" dirty="0"/>
+          </a:p>
+          <a:p>
+            <a:pPr algn="ctr" indent="0" marL="0">
+              <a:buNone/>
+            </a:pPr>
+            <a:r>
+              <a:rPr lang="en-US" sz="4000" b="1" i="1" dirty="0">
+                <a:solidFill>
+                  <a:srgbClr val="FFFFFF"/>
+                </a:solidFill>
+                <a:latin typeface="Arial" pitchFamily="34" charset="0"/>
+                <a:ea typeface="Arial" pitchFamily="34" charset="-122"/>
+                <a:cs typeface="Arial" pitchFamily="34" charset="-120"/>
+              </a:rPr>
+              <a:t>His light will shine.</a:t>
+            </a:r>
+            <a:endParaRPr lang="en-US" sz="4000" dirty="0"/>
+          </a:p>
+          <a:p>
+            <a:pPr algn="ctr" indent="0" marL="0">
+              <a:buNone/>
+            </a:pPr>
+            <a:r>
+              <a:rPr lang="en-US" sz="4000" b="1" i="1" dirty="0">
+                <a:solidFill>
+                  <a:srgbClr val="FFFFFF"/>
+                </a:solidFill>
+                <a:latin typeface="Arial" pitchFamily="34" charset="0"/>
+                <a:ea typeface="Arial" pitchFamily="34" charset="-122"/>
+                <a:cs typeface="Arial" pitchFamily="34" charset="-120"/>
+              </a:rPr>
+              <a:t>God is good (Yes He is),</a:t>
+            </a:r>
+            <a:endParaRPr lang="en-US" sz="4000" dirty="0"/>
+          </a:p>
+          <a:p>
+            <a:pPr algn="ctr" indent="0" marL="0">
+              <a:buNone/>
+            </a:pPr>
+            <a:r>
+              <a:rPr lang="en-US" sz="4000" b="1" i="1" dirty="0">
+                <a:solidFill>
+                  <a:srgbClr val="FFFFFF"/>
+                </a:solidFill>
+                <a:latin typeface="Arial" pitchFamily="34" charset="0"/>
+                <a:ea typeface="Arial" pitchFamily="34" charset="-122"/>
+                <a:cs typeface="Arial" pitchFamily="34" charset="-120"/>
+              </a:rPr>
+              <a:t>God is good (Yes He is), all the time.</a:t>
+            </a:r>
+            <a:endParaRPr lang="en-US" sz="4000" dirty="0"/>
+          </a:p>
+          <a:p>
+            <a:pPr algn="ctr" indent="0" marL="0">
+              <a:buNone/>
+            </a:pPr>
+            <a:r>
+              <a:rPr lang="en-US" sz="4000" b="1" i="1" dirty="0">
+                <a:solidFill>
+                  <a:srgbClr val="FFFFFF"/>
+                </a:solidFill>
+                <a:latin typeface="Arial" pitchFamily="34" charset="0"/>
+                <a:ea typeface="Arial" pitchFamily="34" charset="-122"/>
+                <a:cs typeface="Arial" pitchFamily="34" charset="-120"/>
+              </a:rPr>
+              <a:t>***</a:t>
             </a:r>
             <a:endParaRPr lang="en-US" sz="4000" dirty="0"/>
           </a:p>
@@ -1467,83 +2401,49 @@
               <a:buNone/>
             </a:pPr>
             <a:r>
-              <a:rPr lang="en-US" sz="4000" b="1" i="1" dirty="0">
-                <a:solidFill>
-                  <a:srgbClr val="FFFFFF"/>
-                </a:solidFill>
-                <a:latin typeface="Arial" pitchFamily="34" charset="0"/>
-                <a:ea typeface="Arial" pitchFamily="34" charset="-122"/>
-                <a:cs typeface="Arial" pitchFamily="34" charset="-120"/>
-              </a:rPr>
-              <a:t>God is good (God is good) all the time (all the time).</a:t>
-            </a:r>
-            <a:endParaRPr lang="en-US" sz="4000" dirty="0"/>
-          </a:p>
-          <a:p>
-            <a:pPr algn="ctr" indent="0" marL="0">
-              <a:buNone/>
-            </a:pPr>
-            <a:r>
-              <a:rPr lang="en-US" sz="4000" b="1" i="1" dirty="0">
-                <a:solidFill>
-                  <a:srgbClr val="FFFFFF"/>
-                </a:solidFill>
-                <a:latin typeface="Arial" pitchFamily="34" charset="0"/>
-                <a:ea typeface="Arial" pitchFamily="34" charset="-122"/>
-                <a:cs typeface="Arial" pitchFamily="34" charset="-120"/>
-              </a:rPr>
-              <a:t>He put a song of praise, in this heart of mine.</a:t>
-            </a:r>
-            <a:endParaRPr lang="en-US" sz="4000" dirty="0"/>
-          </a:p>
-          <a:p>
-            <a:pPr algn="ctr" indent="0" marL="0">
-              <a:buNone/>
-            </a:pPr>
-            <a:r>
-              <a:rPr lang="en-US" sz="4000" b="1" i="1" dirty="0">
-                <a:solidFill>
-                  <a:srgbClr val="FFFFFF"/>
-                </a:solidFill>
-                <a:latin typeface="Arial" pitchFamily="34" charset="0"/>
-                <a:ea typeface="Arial" pitchFamily="34" charset="-122"/>
-                <a:cs typeface="Arial" pitchFamily="34" charset="-120"/>
-              </a:rPr>
-              <a:t>God is good (God is good) all the time (all the time).</a:t>
-            </a:r>
-            <a:endParaRPr lang="en-US" sz="4000" dirty="0"/>
-          </a:p>
-          <a:p>
-            <a:pPr algn="ctr" indent="0" marL="0">
-              <a:buNone/>
-            </a:pPr>
-            <a:r>
-              <a:rPr lang="en-US" sz="4000" b="1" i="1" dirty="0">
-                <a:solidFill>
-                  <a:srgbClr val="FFFFFF"/>
-                </a:solidFill>
-                <a:latin typeface="Arial" pitchFamily="34" charset="0"/>
-                <a:ea typeface="Arial" pitchFamily="34" charset="-122"/>
-                <a:cs typeface="Arial" pitchFamily="34" charset="-120"/>
-              </a:rPr>
-              <a:t>Through the darkest night, His light will shine.</a:t>
-            </a:r>
-            <a:endParaRPr lang="en-US" sz="4000" dirty="0"/>
-          </a:p>
-          <a:p>
-            <a:pPr algn="ctr" indent="0" marL="0">
-              <a:buNone/>
-            </a:pPr>
-            <a:r>
-              <a:rPr lang="en-US" sz="4000" b="1" i="1" dirty="0">
-                <a:solidFill>
-                  <a:srgbClr val="FFFFFF"/>
-                </a:solidFill>
-                <a:latin typeface="Arial" pitchFamily="34" charset="0"/>
-                <a:ea typeface="Arial" pitchFamily="34" charset="-122"/>
-                <a:cs typeface="Arial" pitchFamily="34" charset="-120"/>
-              </a:rPr>
-              <a:t>God is good (Yes He is), God is good (Yes He is), all the time.</a:t>
+              <a:rPr lang="en-US" sz="4000" b="1" dirty="0">
+                <a:solidFill>
+                  <a:srgbClr val="FFFFFF"/>
+                </a:solidFill>
+                <a:latin typeface="Arial" pitchFamily="34" charset="0"/>
+                <a:ea typeface="Arial" pitchFamily="34" charset="-122"/>
+                <a:cs typeface="Arial" pitchFamily="34" charset="-120"/>
+              </a:rPr>
+              <a:t>'Cause He has promised</a:t>
+            </a:r>
+            <a:endParaRPr lang="en-US" sz="4000" dirty="0"/>
+          </a:p>
+          <a:p>
+            <a:pPr algn="ctr" indent="0" marL="0">
+              <a:buNone/>
+            </a:pPr>
+            <a:r>
+              <a:rPr lang="en-US" sz="4000" b="1" dirty="0">
+                <a:solidFill>
+                  <a:srgbClr val="FFFFFF"/>
+                </a:solidFill>
+                <a:latin typeface="Arial" pitchFamily="34" charset="0"/>
+                <a:ea typeface="Arial" pitchFamily="34" charset="-122"/>
+                <a:cs typeface="Arial" pitchFamily="34" charset="-120"/>
+              </a:rPr>
+              <a:t>to never leave you nor forsake you</a:t>
+            </a:r>
+            <a:endParaRPr lang="en-US" sz="4000" dirty="0"/>
+          </a:p>
+          <a:p>
+            <a:pPr algn="ctr" indent="0" marL="0">
+              <a:buNone/>
+            </a:pPr>
+            <a:r>
+              <a:rPr lang="en-US" sz="4000" b="1" dirty="0">
+                <a:solidFill>
+                  <a:srgbClr val="FFFFFF"/>
+                </a:solidFill>
+                <a:latin typeface="Arial" pitchFamily="34" charset="0"/>
+                <a:ea typeface="Arial" pitchFamily="34" charset="-122"/>
+                <a:cs typeface="Arial" pitchFamily="34" charset="-120"/>
+              </a:rPr>
+              <a:t>And His Word is true.</a:t>
             </a:r>
             <a:endParaRPr lang="en-US" sz="4000" dirty="0"/>
           </a:p>
@@ -1606,49 +2506,83 @@
               <a:buNone/>
             </a:pPr>
             <a:r>
-              <a:rPr lang="en-US" sz="4000" b="1" dirty="0">
-                <a:solidFill>
-                  <a:srgbClr val="FFFFFF"/>
-                </a:solidFill>
-                <a:latin typeface="Arial" pitchFamily="34" charset="0"/>
-                <a:ea typeface="Arial" pitchFamily="34" charset="-122"/>
-                <a:cs typeface="Arial" pitchFamily="34" charset="-120"/>
-              </a:rPr>
-              <a:t>We were sinners, so unworthy, still for us He chose to die</a:t>
-            </a:r>
-            <a:endParaRPr lang="en-US" sz="4000" dirty="0"/>
-          </a:p>
-          <a:p>
-            <a:pPr algn="ctr" indent="0" marL="0">
-              <a:buNone/>
-            </a:pPr>
-            <a:r>
-              <a:rPr lang="en-US" sz="4000" b="1" dirty="0">
-                <a:solidFill>
-                  <a:srgbClr val="FFFFFF"/>
-                </a:solidFill>
-                <a:latin typeface="Arial" pitchFamily="34" charset="0"/>
-                <a:ea typeface="Arial" pitchFamily="34" charset="-122"/>
-                <a:cs typeface="Arial" pitchFamily="34" charset="-120"/>
-              </a:rPr>
-              <a:t>Filled us with His Holy Spirit. Now we stand and testify</a:t>
-            </a:r>
-            <a:endParaRPr lang="en-US" sz="4000" dirty="0"/>
-          </a:p>
-          <a:p>
-            <a:pPr algn="ctr" indent="0" marL="0">
-              <a:buNone/>
-            </a:pPr>
-            <a:r>
-              <a:rPr lang="en-US" sz="4000" b="1" dirty="0">
-                <a:solidFill>
-                  <a:srgbClr val="FFFFFF"/>
-                </a:solidFill>
-                <a:latin typeface="Arial" pitchFamily="34" charset="0"/>
-                <a:ea typeface="Arial" pitchFamily="34" charset="-122"/>
-                <a:cs typeface="Arial" pitchFamily="34" charset="-120"/>
-              </a:rPr>
-              <a:t>That His love is everlasting and His mercies they will never end.</a:t>
+              <a:rPr lang="en-US" sz="4000" b="1" i="1" dirty="0">
+                <a:solidFill>
+                  <a:srgbClr val="FFFFFF"/>
+                </a:solidFill>
+                <a:latin typeface="Arial" pitchFamily="34" charset="0"/>
+                <a:ea typeface="Arial" pitchFamily="34" charset="-122"/>
+                <a:cs typeface="Arial" pitchFamily="34" charset="-120"/>
+              </a:rPr>
+              <a:t>God is good (God is good)</a:t>
+            </a:r>
+            <a:endParaRPr lang="en-US" sz="4000" dirty="0"/>
+          </a:p>
+          <a:p>
+            <a:pPr algn="ctr" indent="0" marL="0">
+              <a:buNone/>
+            </a:pPr>
+            <a:r>
+              <a:rPr lang="en-US" sz="4000" b="1" i="1" dirty="0">
+                <a:solidFill>
+                  <a:srgbClr val="FFFFFF"/>
+                </a:solidFill>
+                <a:latin typeface="Arial" pitchFamily="34" charset="0"/>
+                <a:ea typeface="Arial" pitchFamily="34" charset="-122"/>
+                <a:cs typeface="Arial" pitchFamily="34" charset="-120"/>
+              </a:rPr>
+              <a:t>all the time (all the time).</a:t>
+            </a:r>
+            <a:endParaRPr lang="en-US" sz="4000" dirty="0"/>
+          </a:p>
+          <a:p>
+            <a:pPr algn="ctr" indent="0" marL="0">
+              <a:buNone/>
+            </a:pPr>
+            <a:r>
+              <a:rPr lang="en-US" sz="4000" b="1" i="1" dirty="0">
+                <a:solidFill>
+                  <a:srgbClr val="FFFFFF"/>
+                </a:solidFill>
+                <a:latin typeface="Arial" pitchFamily="34" charset="0"/>
+                <a:ea typeface="Arial" pitchFamily="34" charset="-122"/>
+                <a:cs typeface="Arial" pitchFamily="34" charset="-120"/>
+              </a:rPr>
+              <a:t>He put a song of praise,</a:t>
+            </a:r>
+            <a:endParaRPr lang="en-US" sz="4000" dirty="0"/>
+          </a:p>
+          <a:p>
+            <a:pPr algn="ctr" indent="0" marL="0">
+              <a:buNone/>
+            </a:pPr>
+            <a:r>
+              <a:rPr lang="en-US" sz="4000" b="1" i="1" dirty="0">
+                <a:solidFill>
+                  <a:srgbClr val="FFFFFF"/>
+                </a:solidFill>
+                <a:latin typeface="Arial" pitchFamily="34" charset="0"/>
+                <a:ea typeface="Arial" pitchFamily="34" charset="-122"/>
+                <a:cs typeface="Arial" pitchFamily="34" charset="-120"/>
+              </a:rPr>
+              <a:t>in this heart of mine.</a:t>
+            </a:r>
+            <a:endParaRPr lang="en-US" sz="4000" dirty="0"/>
+          </a:p>
+          <a:p>
+            <a:pPr algn="ctr" indent="0" marL="0">
+              <a:buNone/>
+            </a:pPr>
+            <a:r>
+              <a:rPr lang="en-US" sz="4000" b="1" i="1" dirty="0">
+                <a:solidFill>
+                  <a:srgbClr val="FFFFFF"/>
+                </a:solidFill>
+                <a:latin typeface="Arial" pitchFamily="34" charset="0"/>
+                <a:ea typeface="Arial" pitchFamily="34" charset="-122"/>
+                <a:cs typeface="Arial" pitchFamily="34" charset="-120"/>
+              </a:rPr>
+              <a:t>God is good (God is good)</a:t>
             </a:r>
             <a:endParaRPr lang="en-US" sz="4000" dirty="0"/>
           </a:p>
@@ -1719,7 +2653,7 @@
                 <a:ea typeface="Arial" pitchFamily="34" charset="-122"/>
                 <a:cs typeface="Arial" pitchFamily="34" charset="-120"/>
               </a:rPr>
-              <a:t>God is good (God is good) all the time (all the time).</a:t>
+              <a:t>all the time (all the time).</a:t>
             </a:r>
             <a:endParaRPr lang="en-US" sz="4000" dirty="0"/>
           </a:p>
@@ -1736,7 +2670,7 @@
                 <a:ea typeface="Arial" pitchFamily="34" charset="-122"/>
                 <a:cs typeface="Arial" pitchFamily="34" charset="-120"/>
               </a:rPr>
-              <a:t>He put a song of praise, in this heart of mine.</a:t>
+              <a:t>Through the darkest night,</a:t>
             </a:r>
             <a:endParaRPr lang="en-US" sz="4000" dirty="0"/>
           </a:p>
@@ -1753,7 +2687,7 @@
                 <a:ea typeface="Arial" pitchFamily="34" charset="-122"/>
                 <a:cs typeface="Arial" pitchFamily="34" charset="-120"/>
               </a:rPr>
-              <a:t>God is good (God is good) all the time (all the time).</a:t>
+              <a:t>His light will shine.</a:t>
             </a:r>
             <a:endParaRPr lang="en-US" sz="4000" dirty="0"/>
           </a:p>
@@ -1770,7 +2704,7 @@
                 <a:ea typeface="Arial" pitchFamily="34" charset="-122"/>
                 <a:cs typeface="Arial" pitchFamily="34" charset="-120"/>
               </a:rPr>
-              <a:t>Through the darkest night, His light will shine.</a:t>
+              <a:t>God is good (Yes He is),</a:t>
             </a:r>
             <a:endParaRPr lang="en-US" sz="4000" dirty="0"/>
           </a:p>
@@ -1787,7 +2721,7 @@
                 <a:ea typeface="Arial" pitchFamily="34" charset="-122"/>
                 <a:cs typeface="Arial" pitchFamily="34" charset="-120"/>
               </a:rPr>
-              <a:t>God is good (Yes He is), God is good (Yes He is), all the time.</a:t>
+              <a:t>God is good (Yes He is), all the time.</a:t>
             </a:r>
             <a:endParaRPr lang="en-US" sz="4000" dirty="0"/>
           </a:p>
@@ -1858,7 +2792,7 @@
                 <a:ea typeface="Arial" pitchFamily="34" charset="-122"/>
                 <a:cs typeface="Arial" pitchFamily="34" charset="-120"/>
               </a:rPr>
-              <a:t>If you're walkin, through the valley, and there are shadows all around,</a:t>
+              <a:t>We were sinners, so unworthy,</a:t>
             </a:r>
             <a:endParaRPr lang="en-US" sz="4000" dirty="0"/>
           </a:p>
@@ -1875,7 +2809,7 @@
                 <a:ea typeface="Arial" pitchFamily="34" charset="-122"/>
                 <a:cs typeface="Arial" pitchFamily="34" charset="-120"/>
               </a:rPr>
-              <a:t>Do not fear, He will guide you. He will keep you safe and sound</a:t>
+              <a:t>still for us He chose to die</a:t>
             </a:r>
             <a:endParaRPr lang="en-US" sz="4000" dirty="0"/>
           </a:p>
@@ -1892,24 +2826,7 @@
                 <a:ea typeface="Arial" pitchFamily="34" charset="-122"/>
                 <a:cs typeface="Arial" pitchFamily="34" charset="-120"/>
               </a:rPr>
-              <a:t>'Cause He has promised to never leave you nor forsake you</a:t>
-            </a:r>
-            <a:endParaRPr lang="en-US" sz="4000" dirty="0"/>
-          </a:p>
-          <a:p>
-            <a:pPr algn="ctr" indent="0" marL="0">
-              <a:buNone/>
-            </a:pPr>
-            <a:r>
-              <a:rPr lang="en-US" sz="4000" b="1" dirty="0">
-                <a:solidFill>
-                  <a:srgbClr val="FFFFFF"/>
-                </a:solidFill>
-                <a:latin typeface="Arial" pitchFamily="34" charset="0"/>
-                <a:ea typeface="Arial" pitchFamily="34" charset="-122"/>
-                <a:cs typeface="Arial" pitchFamily="34" charset="-120"/>
-              </a:rPr>
-              <a:t>And His Word is true.</a:t>
+              <a:t>Filled us with His Holy Spirit.</a:t>
             </a:r>
             <a:endParaRPr lang="en-US" sz="4000" dirty="0"/>
           </a:p>
@@ -1972,6 +2889,111 @@
               <a:buNone/>
             </a:pPr>
             <a:r>
+              <a:rPr lang="en-US" sz="4000" b="1" dirty="0">
+                <a:solidFill>
+                  <a:srgbClr val="FFFFFF"/>
+                </a:solidFill>
+                <a:latin typeface="Arial" pitchFamily="34" charset="0"/>
+                <a:ea typeface="Arial" pitchFamily="34" charset="-122"/>
+                <a:cs typeface="Arial" pitchFamily="34" charset="-120"/>
+              </a:rPr>
+              <a:t>Now we stand and testify</a:t>
+            </a:r>
+            <a:endParaRPr lang="en-US" sz="4000" dirty="0"/>
+          </a:p>
+          <a:p>
+            <a:pPr algn="ctr" indent="0" marL="0">
+              <a:buNone/>
+            </a:pPr>
+            <a:r>
+              <a:rPr lang="en-US" sz="4000" b="1" dirty="0">
+                <a:solidFill>
+                  <a:srgbClr val="FFFFFF"/>
+                </a:solidFill>
+                <a:latin typeface="Arial" pitchFamily="34" charset="0"/>
+                <a:ea typeface="Arial" pitchFamily="34" charset="-122"/>
+                <a:cs typeface="Arial" pitchFamily="34" charset="-120"/>
+              </a:rPr>
+              <a:t>That His love is everlasting</a:t>
+            </a:r>
+            <a:endParaRPr lang="en-US" sz="4000" dirty="0"/>
+          </a:p>
+          <a:p>
+            <a:pPr algn="ctr" indent="0" marL="0">
+              <a:buNone/>
+            </a:pPr>
+            <a:r>
+              <a:rPr lang="en-US" sz="4000" b="1" dirty="0">
+                <a:solidFill>
+                  <a:srgbClr val="FFFFFF"/>
+                </a:solidFill>
+                <a:latin typeface="Arial" pitchFamily="34" charset="0"/>
+                <a:ea typeface="Arial" pitchFamily="34" charset="-122"/>
+                <a:cs typeface="Arial" pitchFamily="34" charset="-120"/>
+              </a:rPr>
+              <a:t>and His mercies they will never end.</a:t>
+            </a:r>
+            <a:endParaRPr lang="en-US" sz="4000" dirty="0"/>
+          </a:p>
+        </p:txBody>
+      </p:sp>
+    </p:spTree>
+  </p:cSld>
+  <p:clrMapOvr>
+    <a:masterClrMapping/>
+  </p:clrMapOvr>
+</p:sld>
+</file>
+
+<file path=ppt/slides/slide7.xml><?xml version="1.0" encoding="utf-8"?>
+<p:sld xmlns:a="http://schemas.openxmlformats.org/drawingml/2006/main" xmlns:r="http://schemas.openxmlformats.org/officeDocument/2006/relationships" xmlns:p="http://schemas.openxmlformats.org/presentationml/2006/main">
+  <p:cSld name="Slide 7">
+    <p:bg>
+      <p:bgPr>
+        <a:solidFill>
+          <a:srgbClr val="000000"/>
+        </a:solidFill>
+      </p:bgPr>
+    </p:bg>
+    <p:spTree>
+      <p:nvGrpSpPr>
+        <p:cNvPr id="1" name=""/>
+        <p:cNvGrpSpPr/>
+        <p:nvPr/>
+      </p:nvGrpSpPr>
+      <p:grpSpPr>
+        <a:xfrm>
+          <a:off x="0" y="0"/>
+          <a:ext cx="0" cy="0"/>
+          <a:chOff x="0" y="0"/>
+          <a:chExt cx="0" cy="0"/>
+        </a:xfrm>
+      </p:grpSpPr>
+      <p:sp>
+        <p:nvSpPr>
+          <p:cNvPr id="2" name="Text 0"/>
+          <p:cNvSpPr txBox="1"/>
+          <p:nvPr/>
+        </p:nvSpPr>
+        <p:spPr>
+          <a:xfrm>
+            <a:off x="548640" y="457200"/>
+            <a:ext cx="11064240" cy="5943600"/>
+          </a:xfrm>
+          <a:prstGeom prst="rect">
+            <a:avLst/>
+          </a:prstGeom>
+          <a:noFill/>
+          <a:ln/>
+        </p:spPr>
+        <p:txBody>
+          <a:bodyPr wrap="square" lIns="0" tIns="0" rIns="0" bIns="0" rtlCol="0" anchor="ctr"/>
+          <a:lstStyle/>
+          <a:p>
+            <a:pPr algn="ctr" indent="0" marL="0">
+              <a:buNone/>
+            </a:pPr>
+            <a:r>
               <a:rPr lang="en-US" sz="4000" b="1" i="1" dirty="0">
                 <a:solidFill>
                   <a:srgbClr val="FFFFFF"/>
@@ -1980,7 +3002,7 @@
                 <a:ea typeface="Arial" pitchFamily="34" charset="-122"/>
                 <a:cs typeface="Arial" pitchFamily="34" charset="-120"/>
               </a:rPr>
-              <a:t>God is good (God is good) all the time (all the time).</a:t>
+              <a:t>God is good (God is good)</a:t>
             </a:r>
             <a:endParaRPr lang="en-US" sz="4000" dirty="0"/>
           </a:p>
@@ -1997,7 +3019,7 @@
                 <a:ea typeface="Arial" pitchFamily="34" charset="-122"/>
                 <a:cs typeface="Arial" pitchFamily="34" charset="-120"/>
               </a:rPr>
-              <a:t>He put a song of praise, in this heart of mine.</a:t>
+              <a:t>all the time (all the time).</a:t>
             </a:r>
             <a:endParaRPr lang="en-US" sz="4000" dirty="0"/>
           </a:p>
@@ -2014,7 +3036,7 @@
                 <a:ea typeface="Arial" pitchFamily="34" charset="-122"/>
                 <a:cs typeface="Arial" pitchFamily="34" charset="-120"/>
               </a:rPr>
-              <a:t>God is good (God is good) all the time (all the time).</a:t>
+              <a:t>He put a song of praise,</a:t>
             </a:r>
             <a:endParaRPr lang="en-US" sz="4000" dirty="0"/>
           </a:p>
@@ -2031,7 +3053,7 @@
                 <a:ea typeface="Arial" pitchFamily="34" charset="-122"/>
                 <a:cs typeface="Arial" pitchFamily="34" charset="-120"/>
               </a:rPr>
-              <a:t>Through the darkest night, His light will shine.</a:t>
+              <a:t>in this heart of mine.</a:t>
             </a:r>
             <a:endParaRPr lang="en-US" sz="4000" dirty="0"/>
           </a:p>
@@ -2048,10 +3070,64 @@
                 <a:ea typeface="Arial" pitchFamily="34" charset="-122"/>
                 <a:cs typeface="Arial" pitchFamily="34" charset="-120"/>
               </a:rPr>
-              <a:t>God is good (Yes He is), God is good (Yes He is), all the time.</a:t>
-            </a:r>
-            <a:endParaRPr lang="en-US" sz="4000" dirty="0"/>
-          </a:p>
+              <a:t>God is good (God is good)</a:t>
+            </a:r>
+            <a:endParaRPr lang="en-US" sz="4000" dirty="0"/>
+          </a:p>
+        </p:txBody>
+      </p:sp>
+    </p:spTree>
+  </p:cSld>
+  <p:clrMapOvr>
+    <a:masterClrMapping/>
+  </p:clrMapOvr>
+</p:sld>
+</file>
+
+<file path=ppt/slides/slide8.xml><?xml version="1.0" encoding="utf-8"?>
+<p:sld xmlns:a="http://schemas.openxmlformats.org/drawingml/2006/main" xmlns:r="http://schemas.openxmlformats.org/officeDocument/2006/relationships" xmlns:p="http://schemas.openxmlformats.org/presentationml/2006/main">
+  <p:cSld name="Slide 8">
+    <p:bg>
+      <p:bgPr>
+        <a:solidFill>
+          <a:srgbClr val="000000"/>
+        </a:solidFill>
+      </p:bgPr>
+    </p:bg>
+    <p:spTree>
+      <p:nvGrpSpPr>
+        <p:cNvPr id="1" name=""/>
+        <p:cNvGrpSpPr/>
+        <p:nvPr/>
+      </p:nvGrpSpPr>
+      <p:grpSpPr>
+        <a:xfrm>
+          <a:off x="0" y="0"/>
+          <a:ext cx="0" cy="0"/>
+          <a:chOff x="0" y="0"/>
+          <a:chExt cx="0" cy="0"/>
+        </a:xfrm>
+      </p:grpSpPr>
+      <p:sp>
+        <p:nvSpPr>
+          <p:cNvPr id="2" name="Text 0"/>
+          <p:cNvSpPr txBox="1"/>
+          <p:nvPr/>
+        </p:nvSpPr>
+        <p:spPr>
+          <a:xfrm>
+            <a:off x="548640" y="457200"/>
+            <a:ext cx="11064240" cy="5943600"/>
+          </a:xfrm>
+          <a:prstGeom prst="rect">
+            <a:avLst/>
+          </a:prstGeom>
+          <a:noFill/>
+          <a:ln/>
+        </p:spPr>
+        <p:txBody>
+          <a:bodyPr wrap="square" lIns="0" tIns="0" rIns="0" bIns="0" rtlCol="0" anchor="ctr"/>
+          <a:lstStyle/>
           <a:p>
             <a:pPr algn="ctr" indent="0" marL="0">
               <a:buNone/>
@@ -2065,7 +3141,197 @@
                 <a:ea typeface="Arial" pitchFamily="34" charset="-122"/>
                 <a:cs typeface="Arial" pitchFamily="34" charset="-120"/>
               </a:rPr>
-              <a:t>***</a:t>
+              <a:t>all the time (all the time).</a:t>
+            </a:r>
+            <a:endParaRPr lang="en-US" sz="4000" dirty="0"/>
+          </a:p>
+          <a:p>
+            <a:pPr algn="ctr" indent="0" marL="0">
+              <a:buNone/>
+            </a:pPr>
+            <a:r>
+              <a:rPr lang="en-US" sz="4000" b="1" i="1" dirty="0">
+                <a:solidFill>
+                  <a:srgbClr val="FFFFFF"/>
+                </a:solidFill>
+                <a:latin typeface="Arial" pitchFamily="34" charset="0"/>
+                <a:ea typeface="Arial" pitchFamily="34" charset="-122"/>
+                <a:cs typeface="Arial" pitchFamily="34" charset="-120"/>
+              </a:rPr>
+              <a:t>Through the darkest night,</a:t>
+            </a:r>
+            <a:endParaRPr lang="en-US" sz="4000" dirty="0"/>
+          </a:p>
+          <a:p>
+            <a:pPr algn="ctr" indent="0" marL="0">
+              <a:buNone/>
+            </a:pPr>
+            <a:r>
+              <a:rPr lang="en-US" sz="4000" b="1" i="1" dirty="0">
+                <a:solidFill>
+                  <a:srgbClr val="FFFFFF"/>
+                </a:solidFill>
+                <a:latin typeface="Arial" pitchFamily="34" charset="0"/>
+                <a:ea typeface="Arial" pitchFamily="34" charset="-122"/>
+                <a:cs typeface="Arial" pitchFamily="34" charset="-120"/>
+              </a:rPr>
+              <a:t>His light will shine.</a:t>
+            </a:r>
+            <a:endParaRPr lang="en-US" sz="4000" dirty="0"/>
+          </a:p>
+          <a:p>
+            <a:pPr algn="ctr" indent="0" marL="0">
+              <a:buNone/>
+            </a:pPr>
+            <a:r>
+              <a:rPr lang="en-US" sz="4000" b="1" i="1" dirty="0">
+                <a:solidFill>
+                  <a:srgbClr val="FFFFFF"/>
+                </a:solidFill>
+                <a:latin typeface="Arial" pitchFamily="34" charset="0"/>
+                <a:ea typeface="Arial" pitchFamily="34" charset="-122"/>
+                <a:cs typeface="Arial" pitchFamily="34" charset="-120"/>
+              </a:rPr>
+              <a:t>God is good (Yes He is),</a:t>
+            </a:r>
+            <a:endParaRPr lang="en-US" sz="4000" dirty="0"/>
+          </a:p>
+          <a:p>
+            <a:pPr algn="ctr" indent="0" marL="0">
+              <a:buNone/>
+            </a:pPr>
+            <a:r>
+              <a:rPr lang="en-US" sz="4000" b="1" i="1" dirty="0">
+                <a:solidFill>
+                  <a:srgbClr val="FFFFFF"/>
+                </a:solidFill>
+                <a:latin typeface="Arial" pitchFamily="34" charset="0"/>
+                <a:ea typeface="Arial" pitchFamily="34" charset="-122"/>
+                <a:cs typeface="Arial" pitchFamily="34" charset="-120"/>
+              </a:rPr>
+              <a:t>God is good (Yes He is), all the time.</a:t>
+            </a:r>
+            <a:endParaRPr lang="en-US" sz="4000" dirty="0"/>
+          </a:p>
+        </p:txBody>
+      </p:sp>
+    </p:spTree>
+  </p:cSld>
+  <p:clrMapOvr>
+    <a:masterClrMapping/>
+  </p:clrMapOvr>
+</p:sld>
+</file>
+
+<file path=ppt/slides/slide9.xml><?xml version="1.0" encoding="utf-8"?>
+<p:sld xmlns:a="http://schemas.openxmlformats.org/drawingml/2006/main" xmlns:r="http://schemas.openxmlformats.org/officeDocument/2006/relationships" xmlns:p="http://schemas.openxmlformats.org/presentationml/2006/main">
+  <p:cSld name="Slide 9">
+    <p:bg>
+      <p:bgPr>
+        <a:solidFill>
+          <a:srgbClr val="000000"/>
+        </a:solidFill>
+      </p:bgPr>
+    </p:bg>
+    <p:spTree>
+      <p:nvGrpSpPr>
+        <p:cNvPr id="1" name=""/>
+        <p:cNvGrpSpPr/>
+        <p:nvPr/>
+      </p:nvGrpSpPr>
+      <p:grpSpPr>
+        <a:xfrm>
+          <a:off x="0" y="0"/>
+          <a:ext cx="0" cy="0"/>
+          <a:chOff x="0" y="0"/>
+          <a:chExt cx="0" cy="0"/>
+        </a:xfrm>
+      </p:grpSpPr>
+      <p:sp>
+        <p:nvSpPr>
+          <p:cNvPr id="2" name="Text 0"/>
+          <p:cNvSpPr txBox="1"/>
+          <p:nvPr/>
+        </p:nvSpPr>
+        <p:spPr>
+          <a:xfrm>
+            <a:off x="548640" y="457200"/>
+            <a:ext cx="11064240" cy="5943600"/>
+          </a:xfrm>
+          <a:prstGeom prst="rect">
+            <a:avLst/>
+          </a:prstGeom>
+          <a:noFill/>
+          <a:ln/>
+        </p:spPr>
+        <p:txBody>
+          <a:bodyPr wrap="square" lIns="0" tIns="0" rIns="0" bIns="0" rtlCol="0" anchor="ctr"/>
+          <a:lstStyle/>
+          <a:p>
+            <a:pPr algn="ctr" indent="0" marL="0">
+              <a:buNone/>
+            </a:pPr>
+            <a:r>
+              <a:rPr lang="en-US" sz="4000" b="1" dirty="0">
+                <a:solidFill>
+                  <a:srgbClr val="FFFFFF"/>
+                </a:solidFill>
+                <a:latin typeface="Arial" pitchFamily="34" charset="0"/>
+                <a:ea typeface="Arial" pitchFamily="34" charset="-122"/>
+                <a:cs typeface="Arial" pitchFamily="34" charset="-120"/>
+              </a:rPr>
+              <a:t>If you're walkin, through the valley,</a:t>
+            </a:r>
+            <a:endParaRPr lang="en-US" sz="4000" dirty="0"/>
+          </a:p>
+          <a:p>
+            <a:pPr algn="ctr" indent="0" marL="0">
+              <a:buNone/>
+            </a:pPr>
+            <a:r>
+              <a:rPr lang="en-US" sz="4000" b="1" dirty="0">
+                <a:solidFill>
+                  <a:srgbClr val="FFFFFF"/>
+                </a:solidFill>
+                <a:latin typeface="Arial" pitchFamily="34" charset="0"/>
+                <a:ea typeface="Arial" pitchFamily="34" charset="-122"/>
+                <a:cs typeface="Arial" pitchFamily="34" charset="-120"/>
+              </a:rPr>
+              <a:t>and there are shadows all around,</a:t>
+            </a:r>
+            <a:endParaRPr lang="en-US" sz="4000" dirty="0"/>
+          </a:p>
+          <a:p>
+            <a:pPr algn="ctr" indent="0" marL="0">
+              <a:buNone/>
+            </a:pPr>
+            <a:r>
+              <a:rPr lang="en-US" sz="4000" b="1" dirty="0">
+                <a:solidFill>
+                  <a:srgbClr val="FFFFFF"/>
+                </a:solidFill>
+                <a:latin typeface="Arial" pitchFamily="34" charset="0"/>
+                <a:ea typeface="Arial" pitchFamily="34" charset="-122"/>
+                <a:cs typeface="Arial" pitchFamily="34" charset="-120"/>
+              </a:rPr>
+              <a:t>Do not fear, He will guide you.</a:t>
+            </a:r>
+            <a:endParaRPr lang="en-US" sz="4000" dirty="0"/>
+          </a:p>
+          <a:p>
+            <a:pPr algn="ctr" indent="0" marL="0">
+              <a:buNone/>
+            </a:pPr>
+            <a:r>
+              <a:rPr lang="en-US" sz="4000" b="1" dirty="0">
+                <a:solidFill>
+                  <a:srgbClr val="FFFFFF"/>
+                </a:solidFill>
+                <a:latin typeface="Arial" pitchFamily="34" charset="0"/>
+                <a:ea typeface="Arial" pitchFamily="34" charset="-122"/>
+                <a:cs typeface="Arial" pitchFamily="34" charset="-120"/>
+              </a:rPr>
+              <a:t>He will keep you safe and sound</a:t>
             </a:r>
             <a:endParaRPr lang="en-US" sz="4000" dirty="0"/>
           </a:p>

</xml_diff>

<commit_message>
Regenerate PowerPoint for song #4 in fubc-en
</commit_message>
<xml_diff>
--- a/fubc-en/4-God Is Good All the Time.pptx
+++ b/fubc-en/4-God Is Good All the Time.pptx
@@ -17,9 +17,10 @@
     <p:sldId id="265" r:id="rId11"/>
     <p:sldId id="266" r:id="rId12"/>
     <p:sldId id="267" r:id="rId13"/>
+    <p:sldId id="268" r:id="rId14"/>
   </p:sldIdLst>
   <p:notesMasterIdLst>
-    <p:notesMasterId r:id="rId14"/>
+    <p:notesMasterId r:id="rId15"/>
   </p:notesMasterIdLst>
   <p:sldSz cx="12192000" cy="6858000"/>
   <p:notesSz cx="6858000" cy="12192000"/>
@@ -801,6 +802,94 @@
             <a:fld id="{F7021451-1387-4CA6-816F-3879F97B5CBC}" type="slidenum">
               <a:rPr lang="en-US"/>
               <a:t>12</a:t>
+            </a:fld>
+            <a:endParaRPr lang="en-US"/>
+          </a:p>
+        </p:txBody>
+      </p:sp>
+    </p:spTree>
+    <p:extLst>
+      <p:ext uri="{BB962C8B-B14F-4D97-AF65-F5344CB8AC3E}">
+        <p14:creationId xmlns:p14="http://schemas.microsoft.com/office/powerpoint/2010/main" val="1024086991"/>
+      </p:ext>
+    </p:extLst>
+  </p:cSld>
+  <p:clrMapOvr>
+    <a:masterClrMapping/>
+  </p:clrMapOvr>
+</p:notes>
+</file>
+
+<file path=ppt/notesSlides/notesSlide13.xml><?xml version="1.0" encoding="utf-8"?>
+<p:notes xmlns:a="http://schemas.openxmlformats.org/drawingml/2006/main" xmlns:r="http://schemas.openxmlformats.org/officeDocument/2006/relationships" xmlns:p="http://schemas.openxmlformats.org/presentationml/2006/main">
+  <p:cSld>
+    <p:spTree>
+      <p:nvGrpSpPr>
+        <p:cNvPr id="1" name=""/>
+        <p:cNvGrpSpPr/>
+        <p:nvPr/>
+      </p:nvGrpSpPr>
+      <p:grpSpPr>
+        <a:xfrm>
+          <a:off x="0" y="0"/>
+          <a:ext cx="0" cy="0"/>
+          <a:chOff x="0" y="0"/>
+          <a:chExt cx="0" cy="0"/>
+        </a:xfrm>
+      </p:grpSpPr>
+      <p:sp>
+        <p:nvSpPr>
+          <p:cNvPr id="2" name="Slide Image Placeholder 1"/>
+          <p:cNvSpPr>
+            <a:spLocks noGrp="1" noRot="1" noChangeAspect="1"/>
+          </p:cNvSpPr>
+          <p:nvPr>
+            <p:ph type="sldImg"/>
+          </p:nvPr>
+        </p:nvSpPr>
+        <p:spPr/>
+      </p:sp>
+      <p:sp>
+        <p:nvSpPr>
+          <p:cNvPr id="3" name="Notes Placeholder 2"/>
+          <p:cNvSpPr>
+            <a:spLocks noGrp="1"/>
+          </p:cNvSpPr>
+          <p:nvPr>
+            <p:ph type="body" idx="1"/>
+          </p:nvPr>
+        </p:nvSpPr>
+        <p:spPr/>
+        <p:txBody>
+          <a:bodyPr/>
+          <a:lstStyle/>
+          <a:p>
+            <a:r>
+              <a:rPr lang="en-US" dirty="0"/>
+              <a:t/>
+            </a:r>
+            <a:endParaRPr lang="en-US" dirty="0"/>
+          </a:p>
+        </p:txBody>
+      </p:sp>
+      <p:sp>
+        <p:nvSpPr>
+          <p:cNvPr id="4" name="Slide Number Placeholder 3"/>
+          <p:cNvSpPr>
+            <a:spLocks noGrp="1"/>
+          </p:cNvSpPr>
+          <p:nvPr>
+            <p:ph type="sldNum" sz="quarter" idx="10"/>
+          </p:nvPr>
+        </p:nvSpPr>
+        <p:spPr/>
+        <p:txBody>
+          <a:bodyPr/>
+          <a:lstStyle/>
+          <a:p>
+            <a:fld id="{F7021451-1387-4CA6-816F-3879F97B5CBC}" type="slidenum">
+              <a:rPr lang="en-US"/>
+              <a:t>13</a:t>
             </a:fld>
             <a:endParaRPr lang="en-US"/>
           </a:p>
@@ -1879,68 +1968,17 @@
               <a:buNone/>
             </a:pPr>
             <a:r>
-              <a:rPr lang="en-US" sz="4000" b="1" dirty="0">
-                <a:solidFill>
-                  <a:srgbClr val="FFFFFF"/>
-                </a:solidFill>
-                <a:latin typeface="Arial" pitchFamily="34" charset="0"/>
-                <a:ea typeface="Arial" pitchFamily="34" charset="-122"/>
-                <a:cs typeface="Arial" pitchFamily="34" charset="-120"/>
-              </a:rPr>
-              <a:t>If you're walkin, through the valley,</a:t>
-            </a:r>
-            <a:endParaRPr lang="en-US" sz="4000" dirty="0"/>
-          </a:p>
-          <a:p>
-            <a:pPr algn="ctr" indent="0" marL="0">
-              <a:buNone/>
-            </a:pPr>
-            <a:r>
-              <a:rPr lang="en-US" sz="4000" b="1" dirty="0">
-                <a:solidFill>
-                  <a:srgbClr val="FFFFFF"/>
-                </a:solidFill>
-                <a:latin typeface="Arial" pitchFamily="34" charset="0"/>
-                <a:ea typeface="Arial" pitchFamily="34" charset="-122"/>
-                <a:cs typeface="Arial" pitchFamily="34" charset="-120"/>
-              </a:rPr>
-              <a:t>and there are shadows all around,</a:t>
-            </a:r>
-            <a:endParaRPr lang="en-US" sz="4000" dirty="0"/>
-          </a:p>
-          <a:p>
-            <a:pPr algn="ctr" indent="0" marL="0">
-              <a:buNone/>
-            </a:pPr>
-            <a:r>
-              <a:rPr lang="en-US" sz="4000" b="1" dirty="0">
-                <a:solidFill>
-                  <a:srgbClr val="FFFFFF"/>
-                </a:solidFill>
-                <a:latin typeface="Arial" pitchFamily="34" charset="0"/>
-                <a:ea typeface="Arial" pitchFamily="34" charset="-122"/>
-                <a:cs typeface="Arial" pitchFamily="34" charset="-120"/>
-              </a:rPr>
-              <a:t>Do not fear, He will guide you.</a:t>
-            </a:r>
-            <a:endParaRPr lang="en-US" sz="4000" dirty="0"/>
-          </a:p>
-          <a:p>
-            <a:pPr algn="ctr" indent="0" marL="0">
-              <a:buNone/>
-            </a:pPr>
-            <a:r>
-              <a:rPr lang="en-US" sz="4000" b="1" dirty="0">
-                <a:solidFill>
-                  <a:srgbClr val="FFFFFF"/>
-                </a:solidFill>
-                <a:latin typeface="Arial" pitchFamily="34" charset="0"/>
-                <a:ea typeface="Arial" pitchFamily="34" charset="-122"/>
-                <a:cs typeface="Arial" pitchFamily="34" charset="-120"/>
-              </a:rPr>
-              <a:t>He will keep you safe and sound</a:t>
-            </a:r>
-            <a:endParaRPr lang="en-US" sz="4000" dirty="0"/>
+              <a:rPr lang="en-US" sz="4800" b="1" dirty="0">
+                <a:solidFill>
+                  <a:srgbClr val="FFFFFF"/>
+                </a:solidFill>
+                <a:latin typeface="Arial" pitchFamily="34" charset="0"/>
+                <a:ea typeface="Arial" pitchFamily="34" charset="-122"/>
+                <a:cs typeface="Arial" pitchFamily="34" charset="-120"/>
+              </a:rPr>
+              <a:t>God Is Good All the Time</a:t>
+            </a:r>
+            <a:endParaRPr lang="en-US" sz="4800" dirty="0"/>
           </a:p>
         </p:txBody>
       </p:sp>
@@ -2001,51 +2039,68 @@
               <a:buNone/>
             </a:pPr>
             <a:r>
-              <a:rPr lang="en-US" sz="4000" b="1" dirty="0">
-                <a:solidFill>
-                  <a:srgbClr val="FFFFFF"/>
-                </a:solidFill>
-                <a:latin typeface="Arial" pitchFamily="34" charset="0"/>
-                <a:ea typeface="Arial" pitchFamily="34" charset="-122"/>
-                <a:cs typeface="Arial" pitchFamily="34" charset="-120"/>
-              </a:rPr>
-              <a:t>'Cause He has promised</a:t>
-            </a:r>
-            <a:endParaRPr lang="en-US" sz="4000" dirty="0"/>
-          </a:p>
-          <a:p>
-            <a:pPr algn="ctr" indent="0" marL="0">
-              <a:buNone/>
-            </a:pPr>
-            <a:r>
-              <a:rPr lang="en-US" sz="4000" b="1" dirty="0">
-                <a:solidFill>
-                  <a:srgbClr val="FFFFFF"/>
-                </a:solidFill>
-                <a:latin typeface="Arial" pitchFamily="34" charset="0"/>
-                <a:ea typeface="Arial" pitchFamily="34" charset="-122"/>
-                <a:cs typeface="Arial" pitchFamily="34" charset="-120"/>
-              </a:rPr>
-              <a:t>to never leave you nor forsake you</a:t>
-            </a:r>
-            <a:endParaRPr lang="en-US" sz="4000" dirty="0"/>
-          </a:p>
-          <a:p>
-            <a:pPr algn="ctr" indent="0" marL="0">
-              <a:buNone/>
-            </a:pPr>
-            <a:r>
-              <a:rPr lang="en-US" sz="4000" b="1" dirty="0">
-                <a:solidFill>
-                  <a:srgbClr val="FFFFFF"/>
-                </a:solidFill>
-                <a:latin typeface="Arial" pitchFamily="34" charset="0"/>
-                <a:ea typeface="Arial" pitchFamily="34" charset="-122"/>
-                <a:cs typeface="Arial" pitchFamily="34" charset="-120"/>
-              </a:rPr>
-              <a:t>And His Word is true.</a:t>
-            </a:r>
-            <a:endParaRPr lang="en-US" sz="4000" dirty="0"/>
+              <a:rPr lang="en-US" sz="4800" b="1" dirty="0">
+                <a:solidFill>
+                  <a:srgbClr val="FFFFFF"/>
+                </a:solidFill>
+                <a:latin typeface="Arial" pitchFamily="34" charset="0"/>
+                <a:ea typeface="Arial" pitchFamily="34" charset="-122"/>
+                <a:cs typeface="Arial" pitchFamily="34" charset="-120"/>
+              </a:rPr>
+              <a:t>If you're walkin, through the valley,</a:t>
+            </a:r>
+            <a:endParaRPr lang="en-US" sz="4800" dirty="0"/>
+          </a:p>
+          <a:p>
+            <a:pPr algn="ctr" indent="0" marL="0">
+              <a:buNone/>
+            </a:pPr>
+            <a:r>
+              <a:rPr lang="en-US" sz="4800" b="1" dirty="0">
+                <a:solidFill>
+                  <a:srgbClr val="FFFFFF"/>
+                </a:solidFill>
+                <a:latin typeface="Arial" pitchFamily="34" charset="0"/>
+                <a:ea typeface="Arial" pitchFamily="34" charset="-122"/>
+                <a:cs typeface="Arial" pitchFamily="34" charset="-120"/>
+              </a:rPr>
+              <a:t>and there are shadows all around,</a:t>
+            </a:r>
+            <a:endParaRPr lang="en-US" sz="4800" dirty="0"/>
+          </a:p>
+          <a:p>
+            <a:pPr algn="ctr" indent="0" marL="0">
+              <a:buNone/>
+            </a:pPr>
+            <a:r>
+              <a:rPr lang="en-US" sz="4800" b="1" dirty="0">
+                <a:solidFill>
+                  <a:srgbClr val="FFFFFF"/>
+                </a:solidFill>
+                <a:latin typeface="Arial" pitchFamily="34" charset="0"/>
+                <a:ea typeface="Arial" pitchFamily="34" charset="-122"/>
+                <a:cs typeface="Arial" pitchFamily="34" charset="-120"/>
+              </a:rPr>
+              <a:t>Do not fear, He will guide you.</a:t>
+            </a:r>
+            <a:endParaRPr lang="en-US" sz="4800" dirty="0"/>
+          </a:p>
+          <a:p>
+            <a:pPr algn="ctr" indent="0" marL="0">
+              <a:buNone/>
+            </a:pPr>
+            <a:r>
+              <a:rPr lang="en-US" sz="4800" b="1" dirty="0">
+                <a:solidFill>
+                  <a:srgbClr val="FFFFFF"/>
+                </a:solidFill>
+                <a:latin typeface="Arial" pitchFamily="34" charset="0"/>
+                <a:ea typeface="Arial" pitchFamily="34" charset="-122"/>
+                <a:cs typeface="Arial" pitchFamily="34" charset="-120"/>
+              </a:rPr>
+              <a:t>He will keep you safe and sound</a:t>
+            </a:r>
+            <a:endParaRPr lang="en-US" sz="4800" dirty="0"/>
           </a:p>
         </p:txBody>
       </p:sp>
@@ -2106,85 +2161,51 @@
               <a:buNone/>
             </a:pPr>
             <a:r>
-              <a:rPr lang="en-US" sz="4000" b="1" i="1" dirty="0">
-                <a:solidFill>
-                  <a:srgbClr val="FFFFFF"/>
-                </a:solidFill>
-                <a:latin typeface="Arial" pitchFamily="34" charset="0"/>
-                <a:ea typeface="Arial" pitchFamily="34" charset="-122"/>
-                <a:cs typeface="Arial" pitchFamily="34" charset="-120"/>
-              </a:rPr>
-              <a:t>God is good (God is good)</a:t>
-            </a:r>
-            <a:endParaRPr lang="en-US" sz="4000" dirty="0"/>
-          </a:p>
-          <a:p>
-            <a:pPr algn="ctr" indent="0" marL="0">
-              <a:buNone/>
-            </a:pPr>
-            <a:r>
-              <a:rPr lang="en-US" sz="4000" b="1" i="1" dirty="0">
-                <a:solidFill>
-                  <a:srgbClr val="FFFFFF"/>
-                </a:solidFill>
-                <a:latin typeface="Arial" pitchFamily="34" charset="0"/>
-                <a:ea typeface="Arial" pitchFamily="34" charset="-122"/>
-                <a:cs typeface="Arial" pitchFamily="34" charset="-120"/>
-              </a:rPr>
-              <a:t>all the time (all the time).</a:t>
-            </a:r>
-            <a:endParaRPr lang="en-US" sz="4000" dirty="0"/>
-          </a:p>
-          <a:p>
-            <a:pPr algn="ctr" indent="0" marL="0">
-              <a:buNone/>
-            </a:pPr>
-            <a:r>
-              <a:rPr lang="en-US" sz="4000" b="1" i="1" dirty="0">
-                <a:solidFill>
-                  <a:srgbClr val="FFFFFF"/>
-                </a:solidFill>
-                <a:latin typeface="Arial" pitchFamily="34" charset="0"/>
-                <a:ea typeface="Arial" pitchFamily="34" charset="-122"/>
-                <a:cs typeface="Arial" pitchFamily="34" charset="-120"/>
-              </a:rPr>
-              <a:t>He put a song of praise,</a:t>
-            </a:r>
-            <a:endParaRPr lang="en-US" sz="4000" dirty="0"/>
-          </a:p>
-          <a:p>
-            <a:pPr algn="ctr" indent="0" marL="0">
-              <a:buNone/>
-            </a:pPr>
-            <a:r>
-              <a:rPr lang="en-US" sz="4000" b="1" i="1" dirty="0">
-                <a:solidFill>
-                  <a:srgbClr val="FFFFFF"/>
-                </a:solidFill>
-                <a:latin typeface="Arial" pitchFamily="34" charset="0"/>
-                <a:ea typeface="Arial" pitchFamily="34" charset="-122"/>
-                <a:cs typeface="Arial" pitchFamily="34" charset="-120"/>
-              </a:rPr>
-              <a:t>in this heart of mine.</a:t>
-            </a:r>
-            <a:endParaRPr lang="en-US" sz="4000" dirty="0"/>
-          </a:p>
-          <a:p>
-            <a:pPr algn="ctr" indent="0" marL="0">
-              <a:buNone/>
-            </a:pPr>
-            <a:r>
-              <a:rPr lang="en-US" sz="4000" b="1" i="1" dirty="0">
-                <a:solidFill>
-                  <a:srgbClr val="FFFFFF"/>
-                </a:solidFill>
-                <a:latin typeface="Arial" pitchFamily="34" charset="0"/>
-                <a:ea typeface="Arial" pitchFamily="34" charset="-122"/>
-                <a:cs typeface="Arial" pitchFamily="34" charset="-120"/>
-              </a:rPr>
-              <a:t>God is good (God is good)</a:t>
-            </a:r>
-            <a:endParaRPr lang="en-US" sz="4000" dirty="0"/>
+              <a:rPr lang="en-US" sz="4800" b="1" dirty="0">
+                <a:solidFill>
+                  <a:srgbClr val="FFFFFF"/>
+                </a:solidFill>
+                <a:latin typeface="Arial" pitchFamily="34" charset="0"/>
+                <a:ea typeface="Arial" pitchFamily="34" charset="-122"/>
+                <a:cs typeface="Arial" pitchFamily="34" charset="-120"/>
+              </a:rPr>
+              <a:t>'Cause He has promised</a:t>
+            </a:r>
+            <a:endParaRPr lang="en-US" sz="4800" dirty="0"/>
+          </a:p>
+          <a:p>
+            <a:pPr algn="ctr" indent="0" marL="0">
+              <a:buNone/>
+            </a:pPr>
+            <a:r>
+              <a:rPr lang="en-US" sz="4800" b="1" dirty="0">
+                <a:solidFill>
+                  <a:srgbClr val="FFFFFF"/>
+                </a:solidFill>
+                <a:latin typeface="Arial" pitchFamily="34" charset="0"/>
+                <a:ea typeface="Arial" pitchFamily="34" charset="-122"/>
+                <a:cs typeface="Arial" pitchFamily="34" charset="-120"/>
+              </a:rPr>
+              <a:t>to never leave you nor forsake you</a:t>
+            </a:r>
+            <a:endParaRPr lang="en-US" sz="4800" dirty="0"/>
+          </a:p>
+          <a:p>
+            <a:pPr algn="ctr" indent="0" marL="0">
+              <a:buNone/>
+            </a:pPr>
+            <a:r>
+              <a:rPr lang="en-US" sz="4800" b="1" dirty="0">
+                <a:solidFill>
+                  <a:srgbClr val="FFFFFF"/>
+                </a:solidFill>
+                <a:latin typeface="Arial" pitchFamily="34" charset="0"/>
+                <a:ea typeface="Arial" pitchFamily="34" charset="-122"/>
+                <a:cs typeface="Arial" pitchFamily="34" charset="-120"/>
+              </a:rPr>
+              <a:t>And His Word is true.</a:t>
+            </a:r>
+            <a:endParaRPr lang="en-US" sz="4800" dirty="0"/>
           </a:p>
         </p:txBody>
       </p:sp>
@@ -2245,7 +2266,24 @@
               <a:buNone/>
             </a:pPr>
             <a:r>
-              <a:rPr lang="en-US" sz="4000" b="1" i="1" dirty="0">
+              <a:rPr lang="en-US" sz="4800" b="1" i="1" dirty="0">
+                <a:solidFill>
+                  <a:srgbClr val="FFFFFF"/>
+                </a:solidFill>
+                <a:latin typeface="Arial" pitchFamily="34" charset="0"/>
+                <a:ea typeface="Arial" pitchFamily="34" charset="-122"/>
+                <a:cs typeface="Arial" pitchFamily="34" charset="-120"/>
+              </a:rPr>
+              <a:t>God is good (God is good)</a:t>
+            </a:r>
+            <a:endParaRPr lang="en-US" sz="4800" dirty="0"/>
+          </a:p>
+          <a:p>
+            <a:pPr algn="ctr" indent="0" marL="0">
+              <a:buNone/>
+            </a:pPr>
+            <a:r>
+              <a:rPr lang="en-US" sz="4800" b="1" i="1" dirty="0">
                 <a:solidFill>
                   <a:srgbClr val="FFFFFF"/>
                 </a:solidFill>
@@ -2255,14 +2293,136 @@
               </a:rPr>
               <a:t>all the time (all the time).</a:t>
             </a:r>
-            <a:endParaRPr lang="en-US" sz="4000" dirty="0"/>
-          </a:p>
-          <a:p>
-            <a:pPr algn="ctr" indent="0" marL="0">
-              <a:buNone/>
-            </a:pPr>
-            <a:r>
-              <a:rPr lang="en-US" sz="4000" b="1" i="1" dirty="0">
+            <a:endParaRPr lang="en-US" sz="4800" dirty="0"/>
+          </a:p>
+          <a:p>
+            <a:pPr algn="ctr" indent="0" marL="0">
+              <a:buNone/>
+            </a:pPr>
+            <a:r>
+              <a:rPr lang="en-US" sz="4800" b="1" i="1" dirty="0">
+                <a:solidFill>
+                  <a:srgbClr val="FFFFFF"/>
+                </a:solidFill>
+                <a:latin typeface="Arial" pitchFamily="34" charset="0"/>
+                <a:ea typeface="Arial" pitchFamily="34" charset="-122"/>
+                <a:cs typeface="Arial" pitchFamily="34" charset="-120"/>
+              </a:rPr>
+              <a:t>He put a song of praise,</a:t>
+            </a:r>
+            <a:endParaRPr lang="en-US" sz="4800" dirty="0"/>
+          </a:p>
+          <a:p>
+            <a:pPr algn="ctr" indent="0" marL="0">
+              <a:buNone/>
+            </a:pPr>
+            <a:r>
+              <a:rPr lang="en-US" sz="4800" b="1" i="1" dirty="0">
+                <a:solidFill>
+                  <a:srgbClr val="FFFFFF"/>
+                </a:solidFill>
+                <a:latin typeface="Arial" pitchFamily="34" charset="0"/>
+                <a:ea typeface="Arial" pitchFamily="34" charset="-122"/>
+                <a:cs typeface="Arial" pitchFamily="34" charset="-120"/>
+              </a:rPr>
+              <a:t>in this heart of mine.</a:t>
+            </a:r>
+            <a:endParaRPr lang="en-US" sz="4800" dirty="0"/>
+          </a:p>
+          <a:p>
+            <a:pPr algn="ctr" indent="0" marL="0">
+              <a:buNone/>
+            </a:pPr>
+            <a:r>
+              <a:rPr lang="en-US" sz="4800" b="1" i="1" dirty="0">
+                <a:solidFill>
+                  <a:srgbClr val="FFFFFF"/>
+                </a:solidFill>
+                <a:latin typeface="Arial" pitchFamily="34" charset="0"/>
+                <a:ea typeface="Arial" pitchFamily="34" charset="-122"/>
+                <a:cs typeface="Arial" pitchFamily="34" charset="-120"/>
+              </a:rPr>
+              <a:t>God is good (God is good)</a:t>
+            </a:r>
+            <a:endParaRPr lang="en-US" sz="4800" dirty="0"/>
+          </a:p>
+        </p:txBody>
+      </p:sp>
+    </p:spTree>
+  </p:cSld>
+  <p:clrMapOvr>
+    <a:masterClrMapping/>
+  </p:clrMapOvr>
+</p:sld>
+</file>
+
+<file path=ppt/slides/slide13.xml><?xml version="1.0" encoding="utf-8"?>
+<p:sld xmlns:a="http://schemas.openxmlformats.org/drawingml/2006/main" xmlns:r="http://schemas.openxmlformats.org/officeDocument/2006/relationships" xmlns:p="http://schemas.openxmlformats.org/presentationml/2006/main">
+  <p:cSld name="Slide 13">
+    <p:bg>
+      <p:bgPr>
+        <a:solidFill>
+          <a:srgbClr val="000000"/>
+        </a:solidFill>
+      </p:bgPr>
+    </p:bg>
+    <p:spTree>
+      <p:nvGrpSpPr>
+        <p:cNvPr id="1" name=""/>
+        <p:cNvGrpSpPr/>
+        <p:nvPr/>
+      </p:nvGrpSpPr>
+      <p:grpSpPr>
+        <a:xfrm>
+          <a:off x="0" y="0"/>
+          <a:ext cx="0" cy="0"/>
+          <a:chOff x="0" y="0"/>
+          <a:chExt cx="0" cy="0"/>
+        </a:xfrm>
+      </p:grpSpPr>
+      <p:sp>
+        <p:nvSpPr>
+          <p:cNvPr id="2" name="Text 0"/>
+          <p:cNvSpPr txBox="1"/>
+          <p:nvPr/>
+        </p:nvSpPr>
+        <p:spPr>
+          <a:xfrm>
+            <a:off x="548640" y="457200"/>
+            <a:ext cx="11064240" cy="5943600"/>
+          </a:xfrm>
+          <a:prstGeom prst="rect">
+            <a:avLst/>
+          </a:prstGeom>
+          <a:noFill/>
+          <a:ln/>
+        </p:spPr>
+        <p:txBody>
+          <a:bodyPr wrap="square" lIns="0" tIns="0" rIns="0" bIns="0" rtlCol="0" anchor="ctr"/>
+          <a:lstStyle/>
+          <a:p>
+            <a:pPr algn="ctr" indent="0" marL="0">
+              <a:buNone/>
+            </a:pPr>
+            <a:r>
+              <a:rPr lang="en-US" sz="4800" b="1" i="1" dirty="0">
+                <a:solidFill>
+                  <a:srgbClr val="FFFFFF"/>
+                </a:solidFill>
+                <a:latin typeface="Arial" pitchFamily="34" charset="0"/>
+                <a:ea typeface="Arial" pitchFamily="34" charset="-122"/>
+                <a:cs typeface="Arial" pitchFamily="34" charset="-120"/>
+              </a:rPr>
+              <a:t>all the time (all the time).</a:t>
+            </a:r>
+            <a:endParaRPr lang="en-US" sz="4800" dirty="0"/>
+          </a:p>
+          <a:p>
+            <a:pPr algn="ctr" indent="0" marL="0">
+              <a:buNone/>
+            </a:pPr>
+            <a:r>
+              <a:rPr lang="en-US" sz="4800" b="1" i="1" dirty="0">
                 <a:solidFill>
                   <a:srgbClr val="FFFFFF"/>
                 </a:solidFill>
@@ -2272,14 +2432,14 @@
               </a:rPr>
               <a:t>Through the darkest night,</a:t>
             </a:r>
-            <a:endParaRPr lang="en-US" sz="4000" dirty="0"/>
-          </a:p>
-          <a:p>
-            <a:pPr algn="ctr" indent="0" marL="0">
-              <a:buNone/>
-            </a:pPr>
-            <a:r>
-              <a:rPr lang="en-US" sz="4000" b="1" i="1" dirty="0">
+            <a:endParaRPr lang="en-US" sz="4800" dirty="0"/>
+          </a:p>
+          <a:p>
+            <a:pPr algn="ctr" indent="0" marL="0">
+              <a:buNone/>
+            </a:pPr>
+            <a:r>
+              <a:rPr lang="en-US" sz="4800" b="1" i="1" dirty="0">
                 <a:solidFill>
                   <a:srgbClr val="FFFFFF"/>
                 </a:solidFill>
@@ -2289,14 +2449,14 @@
               </a:rPr>
               <a:t>His light will shine.</a:t>
             </a:r>
-            <a:endParaRPr lang="en-US" sz="4000" dirty="0"/>
-          </a:p>
-          <a:p>
-            <a:pPr algn="ctr" indent="0" marL="0">
-              <a:buNone/>
-            </a:pPr>
-            <a:r>
-              <a:rPr lang="en-US" sz="4000" b="1" i="1" dirty="0">
+            <a:endParaRPr lang="en-US" sz="4800" dirty="0"/>
+          </a:p>
+          <a:p>
+            <a:pPr algn="ctr" indent="0" marL="0">
+              <a:buNone/>
+            </a:pPr>
+            <a:r>
+              <a:rPr lang="en-US" sz="4800" b="1" i="1" dirty="0">
                 <a:solidFill>
                   <a:srgbClr val="FFFFFF"/>
                 </a:solidFill>
@@ -2306,14 +2466,14 @@
               </a:rPr>
               <a:t>God is good (Yes He is),</a:t>
             </a:r>
-            <a:endParaRPr lang="en-US" sz="4000" dirty="0"/>
-          </a:p>
-          <a:p>
-            <a:pPr algn="ctr" indent="0" marL="0">
-              <a:buNone/>
-            </a:pPr>
-            <a:r>
-              <a:rPr lang="en-US" sz="4000" b="1" i="1" dirty="0">
+            <a:endParaRPr lang="en-US" sz="4800" dirty="0"/>
+          </a:p>
+          <a:p>
+            <a:pPr algn="ctr" indent="0" marL="0">
+              <a:buNone/>
+            </a:pPr>
+            <a:r>
+              <a:rPr lang="en-US" sz="4800" b="1" i="1" dirty="0">
                 <a:solidFill>
                   <a:srgbClr val="FFFFFF"/>
                 </a:solidFill>
@@ -2323,14 +2483,14 @@
               </a:rPr>
               <a:t>God is good (Yes He is), all the time.</a:t>
             </a:r>
-            <a:endParaRPr lang="en-US" sz="4000" dirty="0"/>
-          </a:p>
-          <a:p>
-            <a:pPr algn="ctr" indent="0" marL="0">
-              <a:buNone/>
-            </a:pPr>
-            <a:r>
-              <a:rPr lang="en-US" sz="4000" b="1" i="1" dirty="0">
+            <a:endParaRPr lang="en-US" sz="4800" dirty="0"/>
+          </a:p>
+          <a:p>
+            <a:pPr algn="ctr" indent="0" marL="0">
+              <a:buNone/>
+            </a:pPr>
+            <a:r>
+              <a:rPr lang="en-US" sz="4800" b="1" i="1" dirty="0">
                 <a:solidFill>
                   <a:srgbClr val="FFFFFF"/>
                 </a:solidFill>
@@ -2340,7 +2500,7 @@
               </a:rPr>
               <a:t>***</a:t>
             </a:r>
-            <a:endParaRPr lang="en-US" sz="4000" dirty="0"/>
+            <a:endParaRPr lang="en-US" sz="4800" dirty="0"/>
           </a:p>
         </p:txBody>
       </p:sp>
@@ -2401,51 +2561,68 @@
               <a:buNone/>
             </a:pPr>
             <a:r>
-              <a:rPr lang="en-US" sz="4000" b="1" dirty="0">
-                <a:solidFill>
-                  <a:srgbClr val="FFFFFF"/>
-                </a:solidFill>
-                <a:latin typeface="Arial" pitchFamily="34" charset="0"/>
-                <a:ea typeface="Arial" pitchFamily="34" charset="-122"/>
-                <a:cs typeface="Arial" pitchFamily="34" charset="-120"/>
-              </a:rPr>
-              <a:t>'Cause He has promised</a:t>
-            </a:r>
-            <a:endParaRPr lang="en-US" sz="4000" dirty="0"/>
-          </a:p>
-          <a:p>
-            <a:pPr algn="ctr" indent="0" marL="0">
-              <a:buNone/>
-            </a:pPr>
-            <a:r>
-              <a:rPr lang="en-US" sz="4000" b="1" dirty="0">
-                <a:solidFill>
-                  <a:srgbClr val="FFFFFF"/>
-                </a:solidFill>
-                <a:latin typeface="Arial" pitchFamily="34" charset="0"/>
-                <a:ea typeface="Arial" pitchFamily="34" charset="-122"/>
-                <a:cs typeface="Arial" pitchFamily="34" charset="-120"/>
-              </a:rPr>
-              <a:t>to never leave you nor forsake you</a:t>
-            </a:r>
-            <a:endParaRPr lang="en-US" sz="4000" dirty="0"/>
-          </a:p>
-          <a:p>
-            <a:pPr algn="ctr" indent="0" marL="0">
-              <a:buNone/>
-            </a:pPr>
-            <a:r>
-              <a:rPr lang="en-US" sz="4000" b="1" dirty="0">
-                <a:solidFill>
-                  <a:srgbClr val="FFFFFF"/>
-                </a:solidFill>
-                <a:latin typeface="Arial" pitchFamily="34" charset="0"/>
-                <a:ea typeface="Arial" pitchFamily="34" charset="-122"/>
-                <a:cs typeface="Arial" pitchFamily="34" charset="-120"/>
-              </a:rPr>
-              <a:t>And His Word is true.</a:t>
-            </a:r>
-            <a:endParaRPr lang="en-US" sz="4000" dirty="0"/>
+              <a:rPr lang="en-US" sz="4800" b="1" dirty="0">
+                <a:solidFill>
+                  <a:srgbClr val="FFFFFF"/>
+                </a:solidFill>
+                <a:latin typeface="Arial" pitchFamily="34" charset="0"/>
+                <a:ea typeface="Arial" pitchFamily="34" charset="-122"/>
+                <a:cs typeface="Arial" pitchFamily="34" charset="-120"/>
+              </a:rPr>
+              <a:t>If you're walkin, through the valley,</a:t>
+            </a:r>
+            <a:endParaRPr lang="en-US" sz="4800" dirty="0"/>
+          </a:p>
+          <a:p>
+            <a:pPr algn="ctr" indent="0" marL="0">
+              <a:buNone/>
+            </a:pPr>
+            <a:r>
+              <a:rPr lang="en-US" sz="4800" b="1" dirty="0">
+                <a:solidFill>
+                  <a:srgbClr val="FFFFFF"/>
+                </a:solidFill>
+                <a:latin typeface="Arial" pitchFamily="34" charset="0"/>
+                <a:ea typeface="Arial" pitchFamily="34" charset="-122"/>
+                <a:cs typeface="Arial" pitchFamily="34" charset="-120"/>
+              </a:rPr>
+              <a:t>and there are shadows all around,</a:t>
+            </a:r>
+            <a:endParaRPr lang="en-US" sz="4800" dirty="0"/>
+          </a:p>
+          <a:p>
+            <a:pPr algn="ctr" indent="0" marL="0">
+              <a:buNone/>
+            </a:pPr>
+            <a:r>
+              <a:rPr lang="en-US" sz="4800" b="1" dirty="0">
+                <a:solidFill>
+                  <a:srgbClr val="FFFFFF"/>
+                </a:solidFill>
+                <a:latin typeface="Arial" pitchFamily="34" charset="0"/>
+                <a:ea typeface="Arial" pitchFamily="34" charset="-122"/>
+                <a:cs typeface="Arial" pitchFamily="34" charset="-120"/>
+              </a:rPr>
+              <a:t>Do not fear, He will guide you.</a:t>
+            </a:r>
+            <a:endParaRPr lang="en-US" sz="4800" dirty="0"/>
+          </a:p>
+          <a:p>
+            <a:pPr algn="ctr" indent="0" marL="0">
+              <a:buNone/>
+            </a:pPr>
+            <a:r>
+              <a:rPr lang="en-US" sz="4800" b="1" dirty="0">
+                <a:solidFill>
+                  <a:srgbClr val="FFFFFF"/>
+                </a:solidFill>
+                <a:latin typeface="Arial" pitchFamily="34" charset="0"/>
+                <a:ea typeface="Arial" pitchFamily="34" charset="-122"/>
+                <a:cs typeface="Arial" pitchFamily="34" charset="-120"/>
+              </a:rPr>
+              <a:t>He will keep you safe and sound</a:t>
+            </a:r>
+            <a:endParaRPr lang="en-US" sz="4800" dirty="0"/>
           </a:p>
         </p:txBody>
       </p:sp>
@@ -2506,85 +2683,51 @@
               <a:buNone/>
             </a:pPr>
             <a:r>
-              <a:rPr lang="en-US" sz="4000" b="1" i="1" dirty="0">
-                <a:solidFill>
-                  <a:srgbClr val="FFFFFF"/>
-                </a:solidFill>
-                <a:latin typeface="Arial" pitchFamily="34" charset="0"/>
-                <a:ea typeface="Arial" pitchFamily="34" charset="-122"/>
-                <a:cs typeface="Arial" pitchFamily="34" charset="-120"/>
-              </a:rPr>
-              <a:t>God is good (God is good)</a:t>
-            </a:r>
-            <a:endParaRPr lang="en-US" sz="4000" dirty="0"/>
-          </a:p>
-          <a:p>
-            <a:pPr algn="ctr" indent="0" marL="0">
-              <a:buNone/>
-            </a:pPr>
-            <a:r>
-              <a:rPr lang="en-US" sz="4000" b="1" i="1" dirty="0">
-                <a:solidFill>
-                  <a:srgbClr val="FFFFFF"/>
-                </a:solidFill>
-                <a:latin typeface="Arial" pitchFamily="34" charset="0"/>
-                <a:ea typeface="Arial" pitchFamily="34" charset="-122"/>
-                <a:cs typeface="Arial" pitchFamily="34" charset="-120"/>
-              </a:rPr>
-              <a:t>all the time (all the time).</a:t>
-            </a:r>
-            <a:endParaRPr lang="en-US" sz="4000" dirty="0"/>
-          </a:p>
-          <a:p>
-            <a:pPr algn="ctr" indent="0" marL="0">
-              <a:buNone/>
-            </a:pPr>
-            <a:r>
-              <a:rPr lang="en-US" sz="4000" b="1" i="1" dirty="0">
-                <a:solidFill>
-                  <a:srgbClr val="FFFFFF"/>
-                </a:solidFill>
-                <a:latin typeface="Arial" pitchFamily="34" charset="0"/>
-                <a:ea typeface="Arial" pitchFamily="34" charset="-122"/>
-                <a:cs typeface="Arial" pitchFamily="34" charset="-120"/>
-              </a:rPr>
-              <a:t>He put a song of praise,</a:t>
-            </a:r>
-            <a:endParaRPr lang="en-US" sz="4000" dirty="0"/>
-          </a:p>
-          <a:p>
-            <a:pPr algn="ctr" indent="0" marL="0">
-              <a:buNone/>
-            </a:pPr>
-            <a:r>
-              <a:rPr lang="en-US" sz="4000" b="1" i="1" dirty="0">
-                <a:solidFill>
-                  <a:srgbClr val="FFFFFF"/>
-                </a:solidFill>
-                <a:latin typeface="Arial" pitchFamily="34" charset="0"/>
-                <a:ea typeface="Arial" pitchFamily="34" charset="-122"/>
-                <a:cs typeface="Arial" pitchFamily="34" charset="-120"/>
-              </a:rPr>
-              <a:t>in this heart of mine.</a:t>
-            </a:r>
-            <a:endParaRPr lang="en-US" sz="4000" dirty="0"/>
-          </a:p>
-          <a:p>
-            <a:pPr algn="ctr" indent="0" marL="0">
-              <a:buNone/>
-            </a:pPr>
-            <a:r>
-              <a:rPr lang="en-US" sz="4000" b="1" i="1" dirty="0">
-                <a:solidFill>
-                  <a:srgbClr val="FFFFFF"/>
-                </a:solidFill>
-                <a:latin typeface="Arial" pitchFamily="34" charset="0"/>
-                <a:ea typeface="Arial" pitchFamily="34" charset="-122"/>
-                <a:cs typeface="Arial" pitchFamily="34" charset="-120"/>
-              </a:rPr>
-              <a:t>God is good (God is good)</a:t>
-            </a:r>
-            <a:endParaRPr lang="en-US" sz="4000" dirty="0"/>
+              <a:rPr lang="en-US" sz="4800" b="1" dirty="0">
+                <a:solidFill>
+                  <a:srgbClr val="FFFFFF"/>
+                </a:solidFill>
+                <a:latin typeface="Arial" pitchFamily="34" charset="0"/>
+                <a:ea typeface="Arial" pitchFamily="34" charset="-122"/>
+                <a:cs typeface="Arial" pitchFamily="34" charset="-120"/>
+              </a:rPr>
+              <a:t>'Cause He has promised</a:t>
+            </a:r>
+            <a:endParaRPr lang="en-US" sz="4800" dirty="0"/>
+          </a:p>
+          <a:p>
+            <a:pPr algn="ctr" indent="0" marL="0">
+              <a:buNone/>
+            </a:pPr>
+            <a:r>
+              <a:rPr lang="en-US" sz="4800" b="1" dirty="0">
+                <a:solidFill>
+                  <a:srgbClr val="FFFFFF"/>
+                </a:solidFill>
+                <a:latin typeface="Arial" pitchFamily="34" charset="0"/>
+                <a:ea typeface="Arial" pitchFamily="34" charset="-122"/>
+                <a:cs typeface="Arial" pitchFamily="34" charset="-120"/>
+              </a:rPr>
+              <a:t>to never leave you nor forsake you</a:t>
+            </a:r>
+            <a:endParaRPr lang="en-US" sz="4800" dirty="0"/>
+          </a:p>
+          <a:p>
+            <a:pPr algn="ctr" indent="0" marL="0">
+              <a:buNone/>
+            </a:pPr>
+            <a:r>
+              <a:rPr lang="en-US" sz="4800" b="1" dirty="0">
+                <a:solidFill>
+                  <a:srgbClr val="FFFFFF"/>
+                </a:solidFill>
+                <a:latin typeface="Arial" pitchFamily="34" charset="0"/>
+                <a:ea typeface="Arial" pitchFamily="34" charset="-122"/>
+                <a:cs typeface="Arial" pitchFamily="34" charset="-120"/>
+              </a:rPr>
+              <a:t>And His Word is true.</a:t>
+            </a:r>
+            <a:endParaRPr lang="en-US" sz="4800" dirty="0"/>
           </a:p>
         </p:txBody>
       </p:sp>
@@ -2645,7 +2788,24 @@
               <a:buNone/>
             </a:pPr>
             <a:r>
-              <a:rPr lang="en-US" sz="4000" b="1" i="1" dirty="0">
+              <a:rPr lang="en-US" sz="4800" b="1" i="1" dirty="0">
+                <a:solidFill>
+                  <a:srgbClr val="FFFFFF"/>
+                </a:solidFill>
+                <a:latin typeface="Arial" pitchFamily="34" charset="0"/>
+                <a:ea typeface="Arial" pitchFamily="34" charset="-122"/>
+                <a:cs typeface="Arial" pitchFamily="34" charset="-120"/>
+              </a:rPr>
+              <a:t>God is good (God is good)</a:t>
+            </a:r>
+            <a:endParaRPr lang="en-US" sz="4800" dirty="0"/>
+          </a:p>
+          <a:p>
+            <a:pPr algn="ctr" indent="0" marL="0">
+              <a:buNone/>
+            </a:pPr>
+            <a:r>
+              <a:rPr lang="en-US" sz="4800" b="1" i="1" dirty="0">
                 <a:solidFill>
                   <a:srgbClr val="FFFFFF"/>
                 </a:solidFill>
@@ -2655,75 +2815,58 @@
               </a:rPr>
               <a:t>all the time (all the time).</a:t>
             </a:r>
-            <a:endParaRPr lang="en-US" sz="4000" dirty="0"/>
-          </a:p>
-          <a:p>
-            <a:pPr algn="ctr" indent="0" marL="0">
-              <a:buNone/>
-            </a:pPr>
-            <a:r>
-              <a:rPr lang="en-US" sz="4000" b="1" i="1" dirty="0">
-                <a:solidFill>
-                  <a:srgbClr val="FFFFFF"/>
-                </a:solidFill>
-                <a:latin typeface="Arial" pitchFamily="34" charset="0"/>
-                <a:ea typeface="Arial" pitchFamily="34" charset="-122"/>
-                <a:cs typeface="Arial" pitchFamily="34" charset="-120"/>
-              </a:rPr>
-              <a:t>Through the darkest night,</a:t>
-            </a:r>
-            <a:endParaRPr lang="en-US" sz="4000" dirty="0"/>
-          </a:p>
-          <a:p>
-            <a:pPr algn="ctr" indent="0" marL="0">
-              <a:buNone/>
-            </a:pPr>
-            <a:r>
-              <a:rPr lang="en-US" sz="4000" b="1" i="1" dirty="0">
-                <a:solidFill>
-                  <a:srgbClr val="FFFFFF"/>
-                </a:solidFill>
-                <a:latin typeface="Arial" pitchFamily="34" charset="0"/>
-                <a:ea typeface="Arial" pitchFamily="34" charset="-122"/>
-                <a:cs typeface="Arial" pitchFamily="34" charset="-120"/>
-              </a:rPr>
-              <a:t>His light will shine.</a:t>
-            </a:r>
-            <a:endParaRPr lang="en-US" sz="4000" dirty="0"/>
-          </a:p>
-          <a:p>
-            <a:pPr algn="ctr" indent="0" marL="0">
-              <a:buNone/>
-            </a:pPr>
-            <a:r>
-              <a:rPr lang="en-US" sz="4000" b="1" i="1" dirty="0">
-                <a:solidFill>
-                  <a:srgbClr val="FFFFFF"/>
-                </a:solidFill>
-                <a:latin typeface="Arial" pitchFamily="34" charset="0"/>
-                <a:ea typeface="Arial" pitchFamily="34" charset="-122"/>
-                <a:cs typeface="Arial" pitchFamily="34" charset="-120"/>
-              </a:rPr>
-              <a:t>God is good (Yes He is),</a:t>
-            </a:r>
-            <a:endParaRPr lang="en-US" sz="4000" dirty="0"/>
-          </a:p>
-          <a:p>
-            <a:pPr algn="ctr" indent="0" marL="0">
-              <a:buNone/>
-            </a:pPr>
-            <a:r>
-              <a:rPr lang="en-US" sz="4000" b="1" i="1" dirty="0">
-                <a:solidFill>
-                  <a:srgbClr val="FFFFFF"/>
-                </a:solidFill>
-                <a:latin typeface="Arial" pitchFamily="34" charset="0"/>
-                <a:ea typeface="Arial" pitchFamily="34" charset="-122"/>
-                <a:cs typeface="Arial" pitchFamily="34" charset="-120"/>
-              </a:rPr>
-              <a:t>God is good (Yes He is), all the time.</a:t>
-            </a:r>
-            <a:endParaRPr lang="en-US" sz="4000" dirty="0"/>
+            <a:endParaRPr lang="en-US" sz="4800" dirty="0"/>
+          </a:p>
+          <a:p>
+            <a:pPr algn="ctr" indent="0" marL="0">
+              <a:buNone/>
+            </a:pPr>
+            <a:r>
+              <a:rPr lang="en-US" sz="4800" b="1" i="1" dirty="0">
+                <a:solidFill>
+                  <a:srgbClr val="FFFFFF"/>
+                </a:solidFill>
+                <a:latin typeface="Arial" pitchFamily="34" charset="0"/>
+                <a:ea typeface="Arial" pitchFamily="34" charset="-122"/>
+                <a:cs typeface="Arial" pitchFamily="34" charset="-120"/>
+              </a:rPr>
+              <a:t>He put a song of praise,</a:t>
+            </a:r>
+            <a:endParaRPr lang="en-US" sz="4800" dirty="0"/>
+          </a:p>
+          <a:p>
+            <a:pPr algn="ctr" indent="0" marL="0">
+              <a:buNone/>
+            </a:pPr>
+            <a:r>
+              <a:rPr lang="en-US" sz="4800" b="1" i="1" dirty="0">
+                <a:solidFill>
+                  <a:srgbClr val="FFFFFF"/>
+                </a:solidFill>
+                <a:latin typeface="Arial" pitchFamily="34" charset="0"/>
+                <a:ea typeface="Arial" pitchFamily="34" charset="-122"/>
+                <a:cs typeface="Arial" pitchFamily="34" charset="-120"/>
+              </a:rPr>
+              <a:t>in this heart of mine.</a:t>
+            </a:r>
+            <a:endParaRPr lang="en-US" sz="4800" dirty="0"/>
+          </a:p>
+          <a:p>
+            <a:pPr algn="ctr" indent="0" marL="0">
+              <a:buNone/>
+            </a:pPr>
+            <a:r>
+              <a:rPr lang="en-US" sz="4800" b="1" i="1" dirty="0">
+                <a:solidFill>
+                  <a:srgbClr val="FFFFFF"/>
+                </a:solidFill>
+                <a:latin typeface="Arial" pitchFamily="34" charset="0"/>
+                <a:ea typeface="Arial" pitchFamily="34" charset="-122"/>
+                <a:cs typeface="Arial" pitchFamily="34" charset="-120"/>
+              </a:rPr>
+              <a:t>God is good (God is good)</a:t>
+            </a:r>
+            <a:endParaRPr lang="en-US" sz="4800" dirty="0"/>
           </a:p>
         </p:txBody>
       </p:sp>
@@ -2784,51 +2927,85 @@
               <a:buNone/>
             </a:pPr>
             <a:r>
-              <a:rPr lang="en-US" sz="4000" b="1" dirty="0">
-                <a:solidFill>
-                  <a:srgbClr val="FFFFFF"/>
-                </a:solidFill>
-                <a:latin typeface="Arial" pitchFamily="34" charset="0"/>
-                <a:ea typeface="Arial" pitchFamily="34" charset="-122"/>
-                <a:cs typeface="Arial" pitchFamily="34" charset="-120"/>
-              </a:rPr>
-              <a:t>We were sinners, so unworthy,</a:t>
-            </a:r>
-            <a:endParaRPr lang="en-US" sz="4000" dirty="0"/>
-          </a:p>
-          <a:p>
-            <a:pPr algn="ctr" indent="0" marL="0">
-              <a:buNone/>
-            </a:pPr>
-            <a:r>
-              <a:rPr lang="en-US" sz="4000" b="1" dirty="0">
-                <a:solidFill>
-                  <a:srgbClr val="FFFFFF"/>
-                </a:solidFill>
-                <a:latin typeface="Arial" pitchFamily="34" charset="0"/>
-                <a:ea typeface="Arial" pitchFamily="34" charset="-122"/>
-                <a:cs typeface="Arial" pitchFamily="34" charset="-120"/>
-              </a:rPr>
-              <a:t>still for us He chose to die</a:t>
-            </a:r>
-            <a:endParaRPr lang="en-US" sz="4000" dirty="0"/>
-          </a:p>
-          <a:p>
-            <a:pPr algn="ctr" indent="0" marL="0">
-              <a:buNone/>
-            </a:pPr>
-            <a:r>
-              <a:rPr lang="en-US" sz="4000" b="1" dirty="0">
-                <a:solidFill>
-                  <a:srgbClr val="FFFFFF"/>
-                </a:solidFill>
-                <a:latin typeface="Arial" pitchFamily="34" charset="0"/>
-                <a:ea typeface="Arial" pitchFamily="34" charset="-122"/>
-                <a:cs typeface="Arial" pitchFamily="34" charset="-120"/>
-              </a:rPr>
-              <a:t>Filled us with His Holy Spirit.</a:t>
-            </a:r>
-            <a:endParaRPr lang="en-US" sz="4000" dirty="0"/>
+              <a:rPr lang="en-US" sz="4800" b="1" i="1" dirty="0">
+                <a:solidFill>
+                  <a:srgbClr val="FFFFFF"/>
+                </a:solidFill>
+                <a:latin typeface="Arial" pitchFamily="34" charset="0"/>
+                <a:ea typeface="Arial" pitchFamily="34" charset="-122"/>
+                <a:cs typeface="Arial" pitchFamily="34" charset="-120"/>
+              </a:rPr>
+              <a:t>all the time (all the time).</a:t>
+            </a:r>
+            <a:endParaRPr lang="en-US" sz="4800" dirty="0"/>
+          </a:p>
+          <a:p>
+            <a:pPr algn="ctr" indent="0" marL="0">
+              <a:buNone/>
+            </a:pPr>
+            <a:r>
+              <a:rPr lang="en-US" sz="4800" b="1" i="1" dirty="0">
+                <a:solidFill>
+                  <a:srgbClr val="FFFFFF"/>
+                </a:solidFill>
+                <a:latin typeface="Arial" pitchFamily="34" charset="0"/>
+                <a:ea typeface="Arial" pitchFamily="34" charset="-122"/>
+                <a:cs typeface="Arial" pitchFamily="34" charset="-120"/>
+              </a:rPr>
+              <a:t>Through the darkest night,</a:t>
+            </a:r>
+            <a:endParaRPr lang="en-US" sz="4800" dirty="0"/>
+          </a:p>
+          <a:p>
+            <a:pPr algn="ctr" indent="0" marL="0">
+              <a:buNone/>
+            </a:pPr>
+            <a:r>
+              <a:rPr lang="en-US" sz="4800" b="1" i="1" dirty="0">
+                <a:solidFill>
+                  <a:srgbClr val="FFFFFF"/>
+                </a:solidFill>
+                <a:latin typeface="Arial" pitchFamily="34" charset="0"/>
+                <a:ea typeface="Arial" pitchFamily="34" charset="-122"/>
+                <a:cs typeface="Arial" pitchFamily="34" charset="-120"/>
+              </a:rPr>
+              <a:t>His light will shine.</a:t>
+            </a:r>
+            <a:endParaRPr lang="en-US" sz="4800" dirty="0"/>
+          </a:p>
+          <a:p>
+            <a:pPr algn="ctr" indent="0" marL="0">
+              <a:buNone/>
+            </a:pPr>
+            <a:r>
+              <a:rPr lang="en-US" sz="4800" b="1" i="1" dirty="0">
+                <a:solidFill>
+                  <a:srgbClr val="FFFFFF"/>
+                </a:solidFill>
+                <a:latin typeface="Arial" pitchFamily="34" charset="0"/>
+                <a:ea typeface="Arial" pitchFamily="34" charset="-122"/>
+                <a:cs typeface="Arial" pitchFamily="34" charset="-120"/>
+              </a:rPr>
+              <a:t>God is good (Yes He is),</a:t>
+            </a:r>
+            <a:endParaRPr lang="en-US" sz="4800" dirty="0"/>
+          </a:p>
+          <a:p>
+            <a:pPr algn="ctr" indent="0" marL="0">
+              <a:buNone/>
+            </a:pPr>
+            <a:r>
+              <a:rPr lang="en-US" sz="4800" b="1" i="1" dirty="0">
+                <a:solidFill>
+                  <a:srgbClr val="FFFFFF"/>
+                </a:solidFill>
+                <a:latin typeface="Arial" pitchFamily="34" charset="0"/>
+                <a:ea typeface="Arial" pitchFamily="34" charset="-122"/>
+                <a:cs typeface="Arial" pitchFamily="34" charset="-120"/>
+              </a:rPr>
+              <a:t>God is good (Yes He is), all the time.</a:t>
+            </a:r>
+            <a:endParaRPr lang="en-US" sz="4800" dirty="0"/>
           </a:p>
         </p:txBody>
       </p:sp>
@@ -2889,51 +3066,51 @@
               <a:buNone/>
             </a:pPr>
             <a:r>
-              <a:rPr lang="en-US" sz="4000" b="1" dirty="0">
-                <a:solidFill>
-                  <a:srgbClr val="FFFFFF"/>
-                </a:solidFill>
-                <a:latin typeface="Arial" pitchFamily="34" charset="0"/>
-                <a:ea typeface="Arial" pitchFamily="34" charset="-122"/>
-                <a:cs typeface="Arial" pitchFamily="34" charset="-120"/>
-              </a:rPr>
-              <a:t>Now we stand and testify</a:t>
-            </a:r>
-            <a:endParaRPr lang="en-US" sz="4000" dirty="0"/>
-          </a:p>
-          <a:p>
-            <a:pPr algn="ctr" indent="0" marL="0">
-              <a:buNone/>
-            </a:pPr>
-            <a:r>
-              <a:rPr lang="en-US" sz="4000" b="1" dirty="0">
-                <a:solidFill>
-                  <a:srgbClr val="FFFFFF"/>
-                </a:solidFill>
-                <a:latin typeface="Arial" pitchFamily="34" charset="0"/>
-                <a:ea typeface="Arial" pitchFamily="34" charset="-122"/>
-                <a:cs typeface="Arial" pitchFamily="34" charset="-120"/>
-              </a:rPr>
-              <a:t>That His love is everlasting</a:t>
-            </a:r>
-            <a:endParaRPr lang="en-US" sz="4000" dirty="0"/>
-          </a:p>
-          <a:p>
-            <a:pPr algn="ctr" indent="0" marL="0">
-              <a:buNone/>
-            </a:pPr>
-            <a:r>
-              <a:rPr lang="en-US" sz="4000" b="1" dirty="0">
-                <a:solidFill>
-                  <a:srgbClr val="FFFFFF"/>
-                </a:solidFill>
-                <a:latin typeface="Arial" pitchFamily="34" charset="0"/>
-                <a:ea typeface="Arial" pitchFamily="34" charset="-122"/>
-                <a:cs typeface="Arial" pitchFamily="34" charset="-120"/>
-              </a:rPr>
-              <a:t>and His mercies they will never end.</a:t>
-            </a:r>
-            <a:endParaRPr lang="en-US" sz="4000" dirty="0"/>
+              <a:rPr lang="en-US" sz="4800" b="1" dirty="0">
+                <a:solidFill>
+                  <a:srgbClr val="FFFFFF"/>
+                </a:solidFill>
+                <a:latin typeface="Arial" pitchFamily="34" charset="0"/>
+                <a:ea typeface="Arial" pitchFamily="34" charset="-122"/>
+                <a:cs typeface="Arial" pitchFamily="34" charset="-120"/>
+              </a:rPr>
+              <a:t>We were sinners, so unworthy,</a:t>
+            </a:r>
+            <a:endParaRPr lang="en-US" sz="4800" dirty="0"/>
+          </a:p>
+          <a:p>
+            <a:pPr algn="ctr" indent="0" marL="0">
+              <a:buNone/>
+            </a:pPr>
+            <a:r>
+              <a:rPr lang="en-US" sz="4800" b="1" dirty="0">
+                <a:solidFill>
+                  <a:srgbClr val="FFFFFF"/>
+                </a:solidFill>
+                <a:latin typeface="Arial" pitchFamily="34" charset="0"/>
+                <a:ea typeface="Arial" pitchFamily="34" charset="-122"/>
+                <a:cs typeface="Arial" pitchFamily="34" charset="-120"/>
+              </a:rPr>
+              <a:t>still for us He chose to die</a:t>
+            </a:r>
+            <a:endParaRPr lang="en-US" sz="4800" dirty="0"/>
+          </a:p>
+          <a:p>
+            <a:pPr algn="ctr" indent="0" marL="0">
+              <a:buNone/>
+            </a:pPr>
+            <a:r>
+              <a:rPr lang="en-US" sz="4800" b="1" dirty="0">
+                <a:solidFill>
+                  <a:srgbClr val="FFFFFF"/>
+                </a:solidFill>
+                <a:latin typeface="Arial" pitchFamily="34" charset="0"/>
+                <a:ea typeface="Arial" pitchFamily="34" charset="-122"/>
+                <a:cs typeface="Arial" pitchFamily="34" charset="-120"/>
+              </a:rPr>
+              <a:t>Filled us with His Holy Spirit.</a:t>
+            </a:r>
+            <a:endParaRPr lang="en-US" sz="4800" dirty="0"/>
           </a:p>
         </p:txBody>
       </p:sp>
@@ -2994,85 +3171,51 @@
               <a:buNone/>
             </a:pPr>
             <a:r>
-              <a:rPr lang="en-US" sz="4000" b="1" i="1" dirty="0">
-                <a:solidFill>
-                  <a:srgbClr val="FFFFFF"/>
-                </a:solidFill>
-                <a:latin typeface="Arial" pitchFamily="34" charset="0"/>
-                <a:ea typeface="Arial" pitchFamily="34" charset="-122"/>
-                <a:cs typeface="Arial" pitchFamily="34" charset="-120"/>
-              </a:rPr>
-              <a:t>God is good (God is good)</a:t>
-            </a:r>
-            <a:endParaRPr lang="en-US" sz="4000" dirty="0"/>
-          </a:p>
-          <a:p>
-            <a:pPr algn="ctr" indent="0" marL="0">
-              <a:buNone/>
-            </a:pPr>
-            <a:r>
-              <a:rPr lang="en-US" sz="4000" b="1" i="1" dirty="0">
-                <a:solidFill>
-                  <a:srgbClr val="FFFFFF"/>
-                </a:solidFill>
-                <a:latin typeface="Arial" pitchFamily="34" charset="0"/>
-                <a:ea typeface="Arial" pitchFamily="34" charset="-122"/>
-                <a:cs typeface="Arial" pitchFamily="34" charset="-120"/>
-              </a:rPr>
-              <a:t>all the time (all the time).</a:t>
-            </a:r>
-            <a:endParaRPr lang="en-US" sz="4000" dirty="0"/>
-          </a:p>
-          <a:p>
-            <a:pPr algn="ctr" indent="0" marL="0">
-              <a:buNone/>
-            </a:pPr>
-            <a:r>
-              <a:rPr lang="en-US" sz="4000" b="1" i="1" dirty="0">
-                <a:solidFill>
-                  <a:srgbClr val="FFFFFF"/>
-                </a:solidFill>
-                <a:latin typeface="Arial" pitchFamily="34" charset="0"/>
-                <a:ea typeface="Arial" pitchFamily="34" charset="-122"/>
-                <a:cs typeface="Arial" pitchFamily="34" charset="-120"/>
-              </a:rPr>
-              <a:t>He put a song of praise,</a:t>
-            </a:r>
-            <a:endParaRPr lang="en-US" sz="4000" dirty="0"/>
-          </a:p>
-          <a:p>
-            <a:pPr algn="ctr" indent="0" marL="0">
-              <a:buNone/>
-            </a:pPr>
-            <a:r>
-              <a:rPr lang="en-US" sz="4000" b="1" i="1" dirty="0">
-                <a:solidFill>
-                  <a:srgbClr val="FFFFFF"/>
-                </a:solidFill>
-                <a:latin typeface="Arial" pitchFamily="34" charset="0"/>
-                <a:ea typeface="Arial" pitchFamily="34" charset="-122"/>
-                <a:cs typeface="Arial" pitchFamily="34" charset="-120"/>
-              </a:rPr>
-              <a:t>in this heart of mine.</a:t>
-            </a:r>
-            <a:endParaRPr lang="en-US" sz="4000" dirty="0"/>
-          </a:p>
-          <a:p>
-            <a:pPr algn="ctr" indent="0" marL="0">
-              <a:buNone/>
-            </a:pPr>
-            <a:r>
-              <a:rPr lang="en-US" sz="4000" b="1" i="1" dirty="0">
-                <a:solidFill>
-                  <a:srgbClr val="FFFFFF"/>
-                </a:solidFill>
-                <a:latin typeface="Arial" pitchFamily="34" charset="0"/>
-                <a:ea typeface="Arial" pitchFamily="34" charset="-122"/>
-                <a:cs typeface="Arial" pitchFamily="34" charset="-120"/>
-              </a:rPr>
-              <a:t>God is good (God is good)</a:t>
-            </a:r>
-            <a:endParaRPr lang="en-US" sz="4000" dirty="0"/>
+              <a:rPr lang="en-US" sz="4800" b="1" dirty="0">
+                <a:solidFill>
+                  <a:srgbClr val="FFFFFF"/>
+                </a:solidFill>
+                <a:latin typeface="Arial" pitchFamily="34" charset="0"/>
+                <a:ea typeface="Arial" pitchFamily="34" charset="-122"/>
+                <a:cs typeface="Arial" pitchFamily="34" charset="-120"/>
+              </a:rPr>
+              <a:t>Now we stand and testify</a:t>
+            </a:r>
+            <a:endParaRPr lang="en-US" sz="4800" dirty="0"/>
+          </a:p>
+          <a:p>
+            <a:pPr algn="ctr" indent="0" marL="0">
+              <a:buNone/>
+            </a:pPr>
+            <a:r>
+              <a:rPr lang="en-US" sz="4800" b="1" dirty="0">
+                <a:solidFill>
+                  <a:srgbClr val="FFFFFF"/>
+                </a:solidFill>
+                <a:latin typeface="Arial" pitchFamily="34" charset="0"/>
+                <a:ea typeface="Arial" pitchFamily="34" charset="-122"/>
+                <a:cs typeface="Arial" pitchFamily="34" charset="-120"/>
+              </a:rPr>
+              <a:t>That His love is everlasting</a:t>
+            </a:r>
+            <a:endParaRPr lang="en-US" sz="4800" dirty="0"/>
+          </a:p>
+          <a:p>
+            <a:pPr algn="ctr" indent="0" marL="0">
+              <a:buNone/>
+            </a:pPr>
+            <a:r>
+              <a:rPr lang="en-US" sz="4800" b="1" dirty="0">
+                <a:solidFill>
+                  <a:srgbClr val="FFFFFF"/>
+                </a:solidFill>
+                <a:latin typeface="Arial" pitchFamily="34" charset="0"/>
+                <a:ea typeface="Arial" pitchFamily="34" charset="-122"/>
+                <a:cs typeface="Arial" pitchFamily="34" charset="-120"/>
+              </a:rPr>
+              <a:t>and His mercies they will never end.</a:t>
+            </a:r>
+            <a:endParaRPr lang="en-US" sz="4800" dirty="0"/>
           </a:p>
         </p:txBody>
       </p:sp>
@@ -3133,7 +3276,24 @@
               <a:buNone/>
             </a:pPr>
             <a:r>
-              <a:rPr lang="en-US" sz="4000" b="1" i="1" dirty="0">
+              <a:rPr lang="en-US" sz="4800" b="1" i="1" dirty="0">
+                <a:solidFill>
+                  <a:srgbClr val="FFFFFF"/>
+                </a:solidFill>
+                <a:latin typeface="Arial" pitchFamily="34" charset="0"/>
+                <a:ea typeface="Arial" pitchFamily="34" charset="-122"/>
+                <a:cs typeface="Arial" pitchFamily="34" charset="-120"/>
+              </a:rPr>
+              <a:t>God is good (God is good)</a:t>
+            </a:r>
+            <a:endParaRPr lang="en-US" sz="4800" dirty="0"/>
+          </a:p>
+          <a:p>
+            <a:pPr algn="ctr" indent="0" marL="0">
+              <a:buNone/>
+            </a:pPr>
+            <a:r>
+              <a:rPr lang="en-US" sz="4800" b="1" i="1" dirty="0">
                 <a:solidFill>
                   <a:srgbClr val="FFFFFF"/>
                 </a:solidFill>
@@ -3143,75 +3303,58 @@
               </a:rPr>
               <a:t>all the time (all the time).</a:t>
             </a:r>
-            <a:endParaRPr lang="en-US" sz="4000" dirty="0"/>
-          </a:p>
-          <a:p>
-            <a:pPr algn="ctr" indent="0" marL="0">
-              <a:buNone/>
-            </a:pPr>
-            <a:r>
-              <a:rPr lang="en-US" sz="4000" b="1" i="1" dirty="0">
-                <a:solidFill>
-                  <a:srgbClr val="FFFFFF"/>
-                </a:solidFill>
-                <a:latin typeface="Arial" pitchFamily="34" charset="0"/>
-                <a:ea typeface="Arial" pitchFamily="34" charset="-122"/>
-                <a:cs typeface="Arial" pitchFamily="34" charset="-120"/>
-              </a:rPr>
-              <a:t>Through the darkest night,</a:t>
-            </a:r>
-            <a:endParaRPr lang="en-US" sz="4000" dirty="0"/>
-          </a:p>
-          <a:p>
-            <a:pPr algn="ctr" indent="0" marL="0">
-              <a:buNone/>
-            </a:pPr>
-            <a:r>
-              <a:rPr lang="en-US" sz="4000" b="1" i="1" dirty="0">
-                <a:solidFill>
-                  <a:srgbClr val="FFFFFF"/>
-                </a:solidFill>
-                <a:latin typeface="Arial" pitchFamily="34" charset="0"/>
-                <a:ea typeface="Arial" pitchFamily="34" charset="-122"/>
-                <a:cs typeface="Arial" pitchFamily="34" charset="-120"/>
-              </a:rPr>
-              <a:t>His light will shine.</a:t>
-            </a:r>
-            <a:endParaRPr lang="en-US" sz="4000" dirty="0"/>
-          </a:p>
-          <a:p>
-            <a:pPr algn="ctr" indent="0" marL="0">
-              <a:buNone/>
-            </a:pPr>
-            <a:r>
-              <a:rPr lang="en-US" sz="4000" b="1" i="1" dirty="0">
-                <a:solidFill>
-                  <a:srgbClr val="FFFFFF"/>
-                </a:solidFill>
-                <a:latin typeface="Arial" pitchFamily="34" charset="0"/>
-                <a:ea typeface="Arial" pitchFamily="34" charset="-122"/>
-                <a:cs typeface="Arial" pitchFamily="34" charset="-120"/>
-              </a:rPr>
-              <a:t>God is good (Yes He is),</a:t>
-            </a:r>
-            <a:endParaRPr lang="en-US" sz="4000" dirty="0"/>
-          </a:p>
-          <a:p>
-            <a:pPr algn="ctr" indent="0" marL="0">
-              <a:buNone/>
-            </a:pPr>
-            <a:r>
-              <a:rPr lang="en-US" sz="4000" b="1" i="1" dirty="0">
-                <a:solidFill>
-                  <a:srgbClr val="FFFFFF"/>
-                </a:solidFill>
-                <a:latin typeface="Arial" pitchFamily="34" charset="0"/>
-                <a:ea typeface="Arial" pitchFamily="34" charset="-122"/>
-                <a:cs typeface="Arial" pitchFamily="34" charset="-120"/>
-              </a:rPr>
-              <a:t>God is good (Yes He is), all the time.</a:t>
-            </a:r>
-            <a:endParaRPr lang="en-US" sz="4000" dirty="0"/>
+            <a:endParaRPr lang="en-US" sz="4800" dirty="0"/>
+          </a:p>
+          <a:p>
+            <a:pPr algn="ctr" indent="0" marL="0">
+              <a:buNone/>
+            </a:pPr>
+            <a:r>
+              <a:rPr lang="en-US" sz="4800" b="1" i="1" dirty="0">
+                <a:solidFill>
+                  <a:srgbClr val="FFFFFF"/>
+                </a:solidFill>
+                <a:latin typeface="Arial" pitchFamily="34" charset="0"/>
+                <a:ea typeface="Arial" pitchFamily="34" charset="-122"/>
+                <a:cs typeface="Arial" pitchFamily="34" charset="-120"/>
+              </a:rPr>
+              <a:t>He put a song of praise,</a:t>
+            </a:r>
+            <a:endParaRPr lang="en-US" sz="4800" dirty="0"/>
+          </a:p>
+          <a:p>
+            <a:pPr algn="ctr" indent="0" marL="0">
+              <a:buNone/>
+            </a:pPr>
+            <a:r>
+              <a:rPr lang="en-US" sz="4800" b="1" i="1" dirty="0">
+                <a:solidFill>
+                  <a:srgbClr val="FFFFFF"/>
+                </a:solidFill>
+                <a:latin typeface="Arial" pitchFamily="34" charset="0"/>
+                <a:ea typeface="Arial" pitchFamily="34" charset="-122"/>
+                <a:cs typeface="Arial" pitchFamily="34" charset="-120"/>
+              </a:rPr>
+              <a:t>in this heart of mine.</a:t>
+            </a:r>
+            <a:endParaRPr lang="en-US" sz="4800" dirty="0"/>
+          </a:p>
+          <a:p>
+            <a:pPr algn="ctr" indent="0" marL="0">
+              <a:buNone/>
+            </a:pPr>
+            <a:r>
+              <a:rPr lang="en-US" sz="4800" b="1" i="1" dirty="0">
+                <a:solidFill>
+                  <a:srgbClr val="FFFFFF"/>
+                </a:solidFill>
+                <a:latin typeface="Arial" pitchFamily="34" charset="0"/>
+                <a:ea typeface="Arial" pitchFamily="34" charset="-122"/>
+                <a:cs typeface="Arial" pitchFamily="34" charset="-120"/>
+              </a:rPr>
+              <a:t>God is good (God is good)</a:t>
+            </a:r>
+            <a:endParaRPr lang="en-US" sz="4800" dirty="0"/>
           </a:p>
         </p:txBody>
       </p:sp>
@@ -3272,68 +3415,85 @@
               <a:buNone/>
             </a:pPr>
             <a:r>
-              <a:rPr lang="en-US" sz="4000" b="1" dirty="0">
-                <a:solidFill>
-                  <a:srgbClr val="FFFFFF"/>
-                </a:solidFill>
-                <a:latin typeface="Arial" pitchFamily="34" charset="0"/>
-                <a:ea typeface="Arial" pitchFamily="34" charset="-122"/>
-                <a:cs typeface="Arial" pitchFamily="34" charset="-120"/>
-              </a:rPr>
-              <a:t>If you're walkin, through the valley,</a:t>
-            </a:r>
-            <a:endParaRPr lang="en-US" sz="4000" dirty="0"/>
-          </a:p>
-          <a:p>
-            <a:pPr algn="ctr" indent="0" marL="0">
-              <a:buNone/>
-            </a:pPr>
-            <a:r>
-              <a:rPr lang="en-US" sz="4000" b="1" dirty="0">
-                <a:solidFill>
-                  <a:srgbClr val="FFFFFF"/>
-                </a:solidFill>
-                <a:latin typeface="Arial" pitchFamily="34" charset="0"/>
-                <a:ea typeface="Arial" pitchFamily="34" charset="-122"/>
-                <a:cs typeface="Arial" pitchFamily="34" charset="-120"/>
-              </a:rPr>
-              <a:t>and there are shadows all around,</a:t>
-            </a:r>
-            <a:endParaRPr lang="en-US" sz="4000" dirty="0"/>
-          </a:p>
-          <a:p>
-            <a:pPr algn="ctr" indent="0" marL="0">
-              <a:buNone/>
-            </a:pPr>
-            <a:r>
-              <a:rPr lang="en-US" sz="4000" b="1" dirty="0">
-                <a:solidFill>
-                  <a:srgbClr val="FFFFFF"/>
-                </a:solidFill>
-                <a:latin typeface="Arial" pitchFamily="34" charset="0"/>
-                <a:ea typeface="Arial" pitchFamily="34" charset="-122"/>
-                <a:cs typeface="Arial" pitchFamily="34" charset="-120"/>
-              </a:rPr>
-              <a:t>Do not fear, He will guide you.</a:t>
-            </a:r>
-            <a:endParaRPr lang="en-US" sz="4000" dirty="0"/>
-          </a:p>
-          <a:p>
-            <a:pPr algn="ctr" indent="0" marL="0">
-              <a:buNone/>
-            </a:pPr>
-            <a:r>
-              <a:rPr lang="en-US" sz="4000" b="1" dirty="0">
-                <a:solidFill>
-                  <a:srgbClr val="FFFFFF"/>
-                </a:solidFill>
-                <a:latin typeface="Arial" pitchFamily="34" charset="0"/>
-                <a:ea typeface="Arial" pitchFamily="34" charset="-122"/>
-                <a:cs typeface="Arial" pitchFamily="34" charset="-120"/>
-              </a:rPr>
-              <a:t>He will keep you safe and sound</a:t>
-            </a:r>
-            <a:endParaRPr lang="en-US" sz="4000" dirty="0"/>
+              <a:rPr lang="en-US" sz="4800" b="1" i="1" dirty="0">
+                <a:solidFill>
+                  <a:srgbClr val="FFFFFF"/>
+                </a:solidFill>
+                <a:latin typeface="Arial" pitchFamily="34" charset="0"/>
+                <a:ea typeface="Arial" pitchFamily="34" charset="-122"/>
+                <a:cs typeface="Arial" pitchFamily="34" charset="-120"/>
+              </a:rPr>
+              <a:t>all the time (all the time).</a:t>
+            </a:r>
+            <a:endParaRPr lang="en-US" sz="4800" dirty="0"/>
+          </a:p>
+          <a:p>
+            <a:pPr algn="ctr" indent="0" marL="0">
+              <a:buNone/>
+            </a:pPr>
+            <a:r>
+              <a:rPr lang="en-US" sz="4800" b="1" i="1" dirty="0">
+                <a:solidFill>
+                  <a:srgbClr val="FFFFFF"/>
+                </a:solidFill>
+                <a:latin typeface="Arial" pitchFamily="34" charset="0"/>
+                <a:ea typeface="Arial" pitchFamily="34" charset="-122"/>
+                <a:cs typeface="Arial" pitchFamily="34" charset="-120"/>
+              </a:rPr>
+              <a:t>Through the darkest night,</a:t>
+            </a:r>
+            <a:endParaRPr lang="en-US" sz="4800" dirty="0"/>
+          </a:p>
+          <a:p>
+            <a:pPr algn="ctr" indent="0" marL="0">
+              <a:buNone/>
+            </a:pPr>
+            <a:r>
+              <a:rPr lang="en-US" sz="4800" b="1" i="1" dirty="0">
+                <a:solidFill>
+                  <a:srgbClr val="FFFFFF"/>
+                </a:solidFill>
+                <a:latin typeface="Arial" pitchFamily="34" charset="0"/>
+                <a:ea typeface="Arial" pitchFamily="34" charset="-122"/>
+                <a:cs typeface="Arial" pitchFamily="34" charset="-120"/>
+              </a:rPr>
+              <a:t>His light will shine.</a:t>
+            </a:r>
+            <a:endParaRPr lang="en-US" sz="4800" dirty="0"/>
+          </a:p>
+          <a:p>
+            <a:pPr algn="ctr" indent="0" marL="0">
+              <a:buNone/>
+            </a:pPr>
+            <a:r>
+              <a:rPr lang="en-US" sz="4800" b="1" i="1" dirty="0">
+                <a:solidFill>
+                  <a:srgbClr val="FFFFFF"/>
+                </a:solidFill>
+                <a:latin typeface="Arial" pitchFamily="34" charset="0"/>
+                <a:ea typeface="Arial" pitchFamily="34" charset="-122"/>
+                <a:cs typeface="Arial" pitchFamily="34" charset="-120"/>
+              </a:rPr>
+              <a:t>God is good (Yes He is),</a:t>
+            </a:r>
+            <a:endParaRPr lang="en-US" sz="4800" dirty="0"/>
+          </a:p>
+          <a:p>
+            <a:pPr algn="ctr" indent="0" marL="0">
+              <a:buNone/>
+            </a:pPr>
+            <a:r>
+              <a:rPr lang="en-US" sz="4800" b="1" i="1" dirty="0">
+                <a:solidFill>
+                  <a:srgbClr val="FFFFFF"/>
+                </a:solidFill>
+                <a:latin typeface="Arial" pitchFamily="34" charset="0"/>
+                <a:ea typeface="Arial" pitchFamily="34" charset="-122"/>
+                <a:cs typeface="Arial" pitchFamily="34" charset="-120"/>
+              </a:rPr>
+              <a:t>God is good (Yes He is), all the time.</a:t>
+            </a:r>
+            <a:endParaRPr lang="en-US" sz="4800" dirty="0"/>
           </a:p>
         </p:txBody>
       </p:sp>

</xml_diff>